<commit_message>
Auto commit from batch script.
</commit_message>
<xml_diff>
--- a/05_diagrams/handy powerpoint for diagram drawing_4-3 ratio.pptx
+++ b/05_diagrams/handy powerpoint for diagram drawing_4-3 ratio.pptx
@@ -8,8 +8,8 @@
     <p:notesMasterId r:id="rId8"/>
   </p:notesMasterIdLst>
   <p:sldIdLst>
-    <p:sldId id="2147483143" r:id="rId2"/>
-    <p:sldId id="2147483154" r:id="rId3"/>
+    <p:sldId id="2147483154" r:id="rId2"/>
+    <p:sldId id="2147483155" r:id="rId3"/>
     <p:sldId id="2147483148" r:id="rId4"/>
     <p:sldId id="2147483153" r:id="rId5"/>
     <p:sldId id="2147483152" r:id="rId6"/>
@@ -3505,1255 +3505,6 @@
 <file path=ppt/slides/slide1.xml><?xml version="1.0" encoding="utf-8"?>
 <p:sld xmlns:a="http://schemas.openxmlformats.org/drawingml/2006/main" xmlns:r="http://schemas.openxmlformats.org/officeDocument/2006/relationships" xmlns:p="http://schemas.openxmlformats.org/presentationml/2006/main">
   <p:cSld>
-    <p:spTree>
-      <p:nvGrpSpPr>
-        <p:cNvPr id="1" name="">
-          <a:extLst>
-            <a:ext uri="{FF2B5EF4-FFF2-40B4-BE49-F238E27FC236}">
-              <a16:creationId xmlns:a16="http://schemas.microsoft.com/office/drawing/2014/main" id="{38426621-4286-308E-1FA7-3CB0E352DE9C}"/>
-            </a:ext>
-          </a:extLst>
-        </p:cNvPr>
-        <p:cNvGrpSpPr/>
-        <p:nvPr/>
-      </p:nvGrpSpPr>
-      <p:grpSpPr>
-        <a:xfrm>
-          <a:off x="0" y="0"/>
-          <a:ext cx="0" cy="0"/>
-          <a:chOff x="0" y="0"/>
-          <a:chExt cx="0" cy="0"/>
-        </a:xfrm>
-      </p:grpSpPr>
-      <p:grpSp>
-        <p:nvGrpSpPr>
-          <p:cNvPr id="8" name="Group 7">
-            <a:extLst>
-              <a:ext uri="{FF2B5EF4-FFF2-40B4-BE49-F238E27FC236}">
-                <a16:creationId xmlns:a16="http://schemas.microsoft.com/office/drawing/2014/main" id="{BC39A3BF-6AC8-9217-FFF1-BB7AF94FCC33}"/>
-              </a:ext>
-            </a:extLst>
-          </p:cNvPr>
-          <p:cNvGrpSpPr/>
-          <p:nvPr/>
-        </p:nvGrpSpPr>
-        <p:grpSpPr>
-          <a:xfrm>
-            <a:off x="326326" y="404718"/>
-            <a:ext cx="6746471" cy="2932193"/>
-            <a:chOff x="756287" y="1061422"/>
-            <a:chExt cx="7139713" cy="3103106"/>
-          </a:xfrm>
-        </p:grpSpPr>
-        <p:grpSp>
-          <p:nvGrpSpPr>
-            <p:cNvPr id="21" name="Group 20">
-              <a:extLst>
-                <a:ext uri="{FF2B5EF4-FFF2-40B4-BE49-F238E27FC236}">
-                  <a16:creationId xmlns:a16="http://schemas.microsoft.com/office/drawing/2014/main" id="{EF9ECC37-629F-0D71-BF9A-F3EF7AC29F3F}"/>
-                </a:ext>
-              </a:extLst>
-            </p:cNvPr>
-            <p:cNvGrpSpPr/>
-            <p:nvPr/>
-          </p:nvGrpSpPr>
-          <p:grpSpPr>
-            <a:xfrm>
-              <a:off x="3596973" y="1430753"/>
-              <a:ext cx="1800000" cy="1401932"/>
-              <a:chOff x="3560712" y="1430753"/>
-              <a:chExt cx="1800000" cy="1401932"/>
-            </a:xfrm>
-          </p:grpSpPr>
-          <p:sp>
-            <p:nvSpPr>
-              <p:cNvPr id="3" name="Rectangle: Rounded Corners 2">
-                <a:extLst>
-                  <a:ext uri="{FF2B5EF4-FFF2-40B4-BE49-F238E27FC236}">
-                    <a16:creationId xmlns:a16="http://schemas.microsoft.com/office/drawing/2014/main" id="{056062BC-8236-B016-DE1E-34827C841892}"/>
-                  </a:ext>
-                </a:extLst>
-              </p:cNvPr>
-              <p:cNvSpPr/>
-              <p:nvPr/>
-            </p:nvSpPr>
-            <p:spPr>
-              <a:xfrm>
-                <a:off x="3560712" y="2184685"/>
-                <a:ext cx="1800000" cy="648000"/>
-              </a:xfrm>
-              <a:prstGeom prst="roundRect">
-                <a:avLst/>
-              </a:prstGeom>
-              <a:noFill/>
-              <a:ln w="38100">
-                <a:solidFill>
-                  <a:schemeClr val="tx1">
-                    <a:lumMod val="50000"/>
-                    <a:lumOff val="50000"/>
-                    <a:alpha val="70000"/>
-                  </a:schemeClr>
-                </a:solidFill>
-              </a:ln>
-            </p:spPr>
-            <p:style>
-              <a:lnRef idx="2">
-                <a:schemeClr val="accent1">
-                  <a:shade val="15000"/>
-                </a:schemeClr>
-              </a:lnRef>
-              <a:fillRef idx="1">
-                <a:schemeClr val="accent1"/>
-              </a:fillRef>
-              <a:effectRef idx="0">
-                <a:schemeClr val="accent1"/>
-              </a:effectRef>
-              <a:fontRef idx="minor">
-                <a:schemeClr val="lt1"/>
-              </a:fontRef>
-            </p:style>
-            <p:txBody>
-              <a:bodyPr rtlCol="0" anchor="ctr"/>
-              <a:lstStyle/>
-              <a:p>
-                <a:pPr algn="ctr"/>
-                <a:r>
-                  <a:rPr lang="en-US" altLang="zh-TW" sz="1890" b="1" dirty="0">
-                    <a:solidFill>
-                      <a:schemeClr val="tx1"/>
-                    </a:solidFill>
-                    <a:ea typeface="芫荽" pitchFamily="2" charset="-120"/>
-                    <a:cs typeface="芫荽" pitchFamily="2" charset="-120"/>
-                  </a:rPr>
-                  <a:t>GitHub</a:t>
-                </a:r>
-              </a:p>
-              <a:p>
-                <a:pPr algn="ctr">
-                  <a:lnSpc>
-                    <a:spcPts val="1512"/>
-                  </a:lnSpc>
-                </a:pPr>
-                <a:r>
-                  <a:rPr lang="en-US" sz="1512" dirty="0">
-                    <a:solidFill>
-                      <a:schemeClr val="tx1"/>
-                    </a:solidFill>
-                    <a:ea typeface="芫荽" pitchFamily="2" charset="-120"/>
-                    <a:cs typeface="芫荽" pitchFamily="2" charset="-120"/>
-                  </a:rPr>
-                  <a:t>Canonical</a:t>
-                </a:r>
-              </a:p>
-            </p:txBody>
-          </p:sp>
-          <p:pic>
-            <p:nvPicPr>
-              <p:cNvPr id="1030" name="Picture 6" descr="Logo - Brand Toolkit">
-                <a:extLst>
-                  <a:ext uri="{FF2B5EF4-FFF2-40B4-BE49-F238E27FC236}">
-                    <a16:creationId xmlns:a16="http://schemas.microsoft.com/office/drawing/2014/main" id="{5474D081-F84C-A0E9-A775-2E5ABB98EB5A}"/>
-                  </a:ext>
-                </a:extLst>
-              </p:cNvPr>
-              <p:cNvPicPr>
-                <a:picLocks noChangeAspect="1" noChangeArrowheads="1"/>
-              </p:cNvPicPr>
-              <p:nvPr/>
-            </p:nvPicPr>
-            <p:blipFill rotWithShape="1">
-              <a:blip r:embed="rId2">
-                <a:extLst>
-                  <a:ext uri="{BEBA8EAE-BF5A-486C-A8C5-ECC9F3942E4B}">
-                    <a14:imgProps xmlns:a14="http://schemas.microsoft.com/office/drawing/2010/main">
-                      <a14:imgLayer r:embed="rId3">
-                        <a14:imgEffect>
-                          <a14:brightnessContrast bright="40000"/>
-                        </a14:imgEffect>
-                      </a14:imgLayer>
-                    </a14:imgProps>
-                  </a:ext>
-                  <a:ext uri="{28A0092B-C50C-407E-A947-70E740481C1C}">
-                    <a14:useLocalDpi xmlns:a14="http://schemas.microsoft.com/office/drawing/2010/main" val="0"/>
-                  </a:ext>
-                </a:extLst>
-              </a:blip>
-              <a:srcRect l="15645" t="26693" r="66770" b="25935"/>
-              <a:stretch>
-                <a:fillRect/>
-              </a:stretch>
-            </p:blipFill>
-            <p:spPr bwMode="auto">
-              <a:xfrm>
-                <a:off x="4100712" y="1430753"/>
-                <a:ext cx="720000" cy="720000"/>
-              </a:xfrm>
-              <a:prstGeom prst="rect">
-                <a:avLst/>
-              </a:prstGeom>
-              <a:noFill/>
-              <a:extLst>
-                <a:ext uri="{909E8E84-426E-40DD-AFC4-6F175D3DCCD1}">
-                  <a14:hiddenFill xmlns:a14="http://schemas.microsoft.com/office/drawing/2010/main">
-                    <a:solidFill>
-                      <a:srgbClr val="FFFFFF"/>
-                    </a:solidFill>
-                  </a14:hiddenFill>
-                </a:ext>
-              </a:extLst>
-            </p:spPr>
-          </p:pic>
-        </p:grpSp>
-        <p:sp>
-          <p:nvSpPr>
-            <p:cNvPr id="5" name="Rectangle: Rounded Corners 4">
-              <a:extLst>
-                <a:ext uri="{FF2B5EF4-FFF2-40B4-BE49-F238E27FC236}">
-                  <a16:creationId xmlns:a16="http://schemas.microsoft.com/office/drawing/2014/main" id="{FA0FC9AA-FEF3-E470-4774-5DD7748EE000}"/>
-                </a:ext>
-              </a:extLst>
-            </p:cNvPr>
-            <p:cNvSpPr/>
-            <p:nvPr/>
-          </p:nvSpPr>
-          <p:spPr>
-            <a:xfrm>
-              <a:off x="1097947" y="3516528"/>
-              <a:ext cx="1800000" cy="648000"/>
-            </a:xfrm>
-            <a:prstGeom prst="roundRect">
-              <a:avLst/>
-            </a:prstGeom>
-            <a:noFill/>
-            <a:ln w="38100">
-              <a:solidFill>
-                <a:schemeClr val="tx1">
-                  <a:lumMod val="50000"/>
-                  <a:lumOff val="50000"/>
-                  <a:alpha val="70000"/>
-                </a:schemeClr>
-              </a:solidFill>
-            </a:ln>
-          </p:spPr>
-          <p:style>
-            <a:lnRef idx="2">
-              <a:schemeClr val="accent1">
-                <a:shade val="15000"/>
-              </a:schemeClr>
-            </a:lnRef>
-            <a:fillRef idx="1">
-              <a:schemeClr val="accent1"/>
-            </a:fillRef>
-            <a:effectRef idx="0">
-              <a:schemeClr val="accent1"/>
-            </a:effectRef>
-            <a:fontRef idx="minor">
-              <a:schemeClr val="lt1"/>
-            </a:fontRef>
-          </p:style>
-          <p:txBody>
-            <a:bodyPr rtlCol="0" anchor="ctr"/>
-            <a:lstStyle/>
-            <a:p>
-              <a:pPr algn="ctr"/>
-              <a:r>
-                <a:rPr lang="en-US" altLang="zh-TW" sz="1890" b="1" dirty="0">
-                  <a:solidFill>
-                    <a:schemeClr val="tx1"/>
-                  </a:solidFill>
-                  <a:ea typeface="芫荽" pitchFamily="2" charset="-120"/>
-                  <a:cs typeface="芫荽" pitchFamily="2" charset="-120"/>
-                </a:rPr>
-                <a:t>Local</a:t>
-              </a:r>
-            </a:p>
-            <a:p>
-              <a:pPr algn="ctr">
-                <a:lnSpc>
-                  <a:spcPts val="1512"/>
-                </a:lnSpc>
-              </a:pPr>
-              <a:r>
-                <a:rPr lang="en-US" sz="1512" dirty="0">
-                  <a:solidFill>
-                    <a:schemeClr val="tx1"/>
-                  </a:solidFill>
-                  <a:ea typeface="芫荽" pitchFamily="2" charset="-120"/>
-                  <a:cs typeface="芫荽" pitchFamily="2" charset="-120"/>
-                </a:rPr>
-                <a:t>Editing area</a:t>
-              </a:r>
-            </a:p>
-          </p:txBody>
-        </p:sp>
-        <p:grpSp>
-          <p:nvGrpSpPr>
-            <p:cNvPr id="23" name="Group 22">
-              <a:extLst>
-                <a:ext uri="{FF2B5EF4-FFF2-40B4-BE49-F238E27FC236}">
-                  <a16:creationId xmlns:a16="http://schemas.microsoft.com/office/drawing/2014/main" id="{F5030667-B118-8D8E-5457-503CA83A3CA5}"/>
-                </a:ext>
-              </a:extLst>
-            </p:cNvPr>
-            <p:cNvGrpSpPr/>
-            <p:nvPr/>
-          </p:nvGrpSpPr>
-          <p:grpSpPr>
-            <a:xfrm>
-              <a:off x="6096000" y="2709033"/>
-              <a:ext cx="1800000" cy="1455495"/>
-              <a:chOff x="6096000" y="2709033"/>
-              <a:chExt cx="1800000" cy="1455495"/>
-            </a:xfrm>
-          </p:grpSpPr>
-          <p:sp>
-            <p:nvSpPr>
-              <p:cNvPr id="4" name="Rectangle: Rounded Corners 3">
-                <a:extLst>
-                  <a:ext uri="{FF2B5EF4-FFF2-40B4-BE49-F238E27FC236}">
-                    <a16:creationId xmlns:a16="http://schemas.microsoft.com/office/drawing/2014/main" id="{049280FD-36E1-E6BD-9890-0445A94E9405}"/>
-                  </a:ext>
-                </a:extLst>
-              </p:cNvPr>
-              <p:cNvSpPr/>
-              <p:nvPr/>
-            </p:nvSpPr>
-            <p:spPr>
-              <a:xfrm>
-                <a:off x="6096000" y="3516528"/>
-                <a:ext cx="1800000" cy="648000"/>
-              </a:xfrm>
-              <a:prstGeom prst="roundRect">
-                <a:avLst/>
-              </a:prstGeom>
-              <a:noFill/>
-              <a:ln w="38100">
-                <a:solidFill>
-                  <a:schemeClr val="tx1">
-                    <a:lumMod val="50000"/>
-                    <a:lumOff val="50000"/>
-                    <a:alpha val="70000"/>
-                  </a:schemeClr>
-                </a:solidFill>
-              </a:ln>
-            </p:spPr>
-            <p:style>
-              <a:lnRef idx="2">
-                <a:schemeClr val="accent1">
-                  <a:shade val="15000"/>
-                </a:schemeClr>
-              </a:lnRef>
-              <a:fillRef idx="1">
-                <a:schemeClr val="accent1"/>
-              </a:fillRef>
-              <a:effectRef idx="0">
-                <a:schemeClr val="accent1"/>
-              </a:effectRef>
-              <a:fontRef idx="minor">
-                <a:schemeClr val="lt1"/>
-              </a:fontRef>
-            </p:style>
-            <p:txBody>
-              <a:bodyPr rtlCol="0" anchor="ctr"/>
-              <a:lstStyle/>
-              <a:p>
-                <a:pPr algn="ctr"/>
-                <a:r>
-                  <a:rPr lang="en-US" altLang="zh-TW" sz="1890" b="1" dirty="0">
-                    <a:solidFill>
-                      <a:schemeClr val="tx1"/>
-                    </a:solidFill>
-                    <a:ea typeface="芫荽" pitchFamily="2" charset="-120"/>
-                    <a:cs typeface="芫荽" pitchFamily="2" charset="-120"/>
-                  </a:rPr>
-                  <a:t>MIT Athena</a:t>
-                </a:r>
-              </a:p>
-              <a:p>
-                <a:pPr algn="ctr">
-                  <a:lnSpc>
-                    <a:spcPts val="1512"/>
-                  </a:lnSpc>
-                </a:pPr>
-                <a:r>
-                  <a:rPr lang="en-US" sz="1512" dirty="0">
-                    <a:solidFill>
-                      <a:schemeClr val="tx1"/>
-                    </a:solidFill>
-                    <a:ea typeface="芫荽" pitchFamily="2" charset="-120"/>
-                    <a:cs typeface="芫荽" pitchFamily="2" charset="-120"/>
-                  </a:rPr>
-                  <a:t>Deployment</a:t>
-                </a:r>
-              </a:p>
-            </p:txBody>
-          </p:sp>
-          <p:pic>
-            <p:nvPicPr>
-              <p:cNvPr id="1032" name="Picture 8" descr="MIT Athena · GitHub">
-                <a:extLst>
-                  <a:ext uri="{FF2B5EF4-FFF2-40B4-BE49-F238E27FC236}">
-                    <a16:creationId xmlns:a16="http://schemas.microsoft.com/office/drawing/2014/main" id="{99DC9E13-9045-39FB-36EA-EF88DE3BBB80}"/>
-                  </a:ext>
-                </a:extLst>
-              </p:cNvPr>
-              <p:cNvPicPr>
-                <a:picLocks noChangeAspect="1" noChangeArrowheads="1"/>
-              </p:cNvPicPr>
-              <p:nvPr/>
-            </p:nvPicPr>
-            <p:blipFill>
-              <a:blip r:embed="rId4">
-                <a:extLst>
-                  <a:ext uri="{28A0092B-C50C-407E-A947-70E740481C1C}">
-                    <a14:useLocalDpi xmlns:a14="http://schemas.microsoft.com/office/drawing/2010/main" val="0"/>
-                  </a:ext>
-                </a:extLst>
-              </a:blip>
-              <a:srcRect/>
-              <a:stretch>
-                <a:fillRect/>
-              </a:stretch>
-            </p:blipFill>
-            <p:spPr bwMode="auto">
-              <a:xfrm>
-                <a:off x="6636000" y="2709033"/>
-                <a:ext cx="720000" cy="720000"/>
-              </a:xfrm>
-              <a:prstGeom prst="rect">
-                <a:avLst/>
-              </a:prstGeom>
-              <a:noFill/>
-              <a:extLst>
-                <a:ext uri="{909E8E84-426E-40DD-AFC4-6F175D3DCCD1}">
-                  <a14:hiddenFill xmlns:a14="http://schemas.microsoft.com/office/drawing/2010/main">
-                    <a:solidFill>
-                      <a:srgbClr val="FFFFFF"/>
-                    </a:solidFill>
-                  </a14:hiddenFill>
-                </a:ext>
-              </a:extLst>
-            </p:spPr>
-          </p:pic>
-        </p:grpSp>
-        <p:grpSp>
-          <p:nvGrpSpPr>
-            <p:cNvPr id="30" name="Group 29">
-              <a:extLst>
-                <a:ext uri="{FF2B5EF4-FFF2-40B4-BE49-F238E27FC236}">
-                  <a16:creationId xmlns:a16="http://schemas.microsoft.com/office/drawing/2014/main" id="{33203EEE-68FD-CFA2-42DE-878631D7A671}"/>
-                </a:ext>
-              </a:extLst>
-            </p:cNvPr>
-            <p:cNvGrpSpPr/>
-            <p:nvPr/>
-          </p:nvGrpSpPr>
-          <p:grpSpPr>
-            <a:xfrm>
-              <a:off x="3011494" y="2988469"/>
-              <a:ext cx="2970959" cy="360000"/>
-              <a:chOff x="3045528" y="2988469"/>
-              <a:chExt cx="2970959" cy="360000"/>
-            </a:xfrm>
-          </p:grpSpPr>
-          <p:cxnSp>
-            <p:nvCxnSpPr>
-              <p:cNvPr id="26" name="Straight Arrow Connector 25">
-                <a:extLst>
-                  <a:ext uri="{FF2B5EF4-FFF2-40B4-BE49-F238E27FC236}">
-                    <a16:creationId xmlns:a16="http://schemas.microsoft.com/office/drawing/2014/main" id="{B82E9EF3-856B-0DB0-B5E9-BDF3A83580C3}"/>
-                  </a:ext>
-                </a:extLst>
-              </p:cNvPr>
-              <p:cNvCxnSpPr>
-                <a:cxnSpLocks/>
-              </p:cNvCxnSpPr>
-              <p:nvPr/>
-            </p:nvCxnSpPr>
-            <p:spPr>
-              <a:xfrm flipV="1">
-                <a:off x="3045528" y="2988469"/>
-                <a:ext cx="360000" cy="360000"/>
-              </a:xfrm>
-              <a:prstGeom prst="straightConnector1">
-                <a:avLst/>
-              </a:prstGeom>
-              <a:ln w="38100">
-                <a:solidFill>
-                  <a:schemeClr val="accent6">
-                    <a:lumMod val="75000"/>
-                  </a:schemeClr>
-                </a:solidFill>
-                <a:tailEnd type="triangle"/>
-              </a:ln>
-            </p:spPr>
-            <p:style>
-              <a:lnRef idx="1">
-                <a:schemeClr val="accent1"/>
-              </a:lnRef>
-              <a:fillRef idx="0">
-                <a:schemeClr val="accent1"/>
-              </a:fillRef>
-              <a:effectRef idx="0">
-                <a:schemeClr val="accent1"/>
-              </a:effectRef>
-              <a:fontRef idx="minor">
-                <a:schemeClr val="tx1"/>
-              </a:fontRef>
-            </p:style>
-          </p:cxnSp>
-          <p:cxnSp>
-            <p:nvCxnSpPr>
-              <p:cNvPr id="28" name="Straight Arrow Connector 27">
-                <a:extLst>
-                  <a:ext uri="{FF2B5EF4-FFF2-40B4-BE49-F238E27FC236}">
-                    <a16:creationId xmlns:a16="http://schemas.microsoft.com/office/drawing/2014/main" id="{EFB70296-721C-F34A-48A2-13078FAB7880}"/>
-                  </a:ext>
-                </a:extLst>
-              </p:cNvPr>
-              <p:cNvCxnSpPr>
-                <a:cxnSpLocks/>
-              </p:cNvCxnSpPr>
-              <p:nvPr/>
-            </p:nvCxnSpPr>
-            <p:spPr>
-              <a:xfrm>
-                <a:off x="5656487" y="2988469"/>
-                <a:ext cx="360000" cy="360000"/>
-              </a:xfrm>
-              <a:prstGeom prst="straightConnector1">
-                <a:avLst/>
-              </a:prstGeom>
-              <a:ln w="38100">
-                <a:solidFill>
-                  <a:schemeClr val="accent6">
-                    <a:lumMod val="75000"/>
-                  </a:schemeClr>
-                </a:solidFill>
-                <a:tailEnd type="triangle"/>
-              </a:ln>
-            </p:spPr>
-            <p:style>
-              <a:lnRef idx="1">
-                <a:schemeClr val="accent1"/>
-              </a:lnRef>
-              <a:fillRef idx="0">
-                <a:schemeClr val="accent1"/>
-              </a:fillRef>
-              <a:effectRef idx="0">
-                <a:schemeClr val="accent1"/>
-              </a:effectRef>
-              <a:fontRef idx="minor">
-                <a:schemeClr val="tx1"/>
-              </a:fontRef>
-            </p:style>
-          </p:cxnSp>
-        </p:grpSp>
-        <p:cxnSp>
-          <p:nvCxnSpPr>
-            <p:cNvPr id="34" name="Straight Arrow Connector 33">
-              <a:extLst>
-                <a:ext uri="{FF2B5EF4-FFF2-40B4-BE49-F238E27FC236}">
-                  <a16:creationId xmlns:a16="http://schemas.microsoft.com/office/drawing/2014/main" id="{40D3B128-3A54-86B8-065D-A2F6AB0C7A5E}"/>
-                </a:ext>
-              </a:extLst>
-            </p:cNvPr>
-            <p:cNvCxnSpPr/>
-            <p:nvPr/>
-          </p:nvCxnSpPr>
-          <p:spPr>
-            <a:xfrm>
-              <a:off x="3371494" y="3834612"/>
-              <a:ext cx="2250959" cy="0"/>
-            </a:xfrm>
-            <a:prstGeom prst="straightConnector1">
-              <a:avLst/>
-            </a:prstGeom>
-            <a:ln w="38100">
-              <a:solidFill>
-                <a:schemeClr val="bg1">
-                  <a:lumMod val="75000"/>
-                </a:schemeClr>
-              </a:solidFill>
-              <a:tailEnd type="triangle"/>
-            </a:ln>
-          </p:spPr>
-          <p:style>
-            <a:lnRef idx="1">
-              <a:schemeClr val="accent1"/>
-            </a:lnRef>
-            <a:fillRef idx="0">
-              <a:schemeClr val="accent1"/>
-            </a:fillRef>
-            <a:effectRef idx="0">
-              <a:schemeClr val="accent1"/>
-            </a:effectRef>
-            <a:fontRef idx="minor">
-              <a:schemeClr val="tx1"/>
-            </a:fontRef>
-          </p:style>
-        </p:cxnSp>
-        <p:sp>
-          <p:nvSpPr>
-            <p:cNvPr id="35" name="TextBox 34">
-              <a:extLst>
-                <a:ext uri="{FF2B5EF4-FFF2-40B4-BE49-F238E27FC236}">
-                  <a16:creationId xmlns:a16="http://schemas.microsoft.com/office/drawing/2014/main" id="{D825E2EB-5161-B4FE-1557-4AF41C8C1EA6}"/>
-                </a:ext>
-              </a:extLst>
-            </p:cNvPr>
-            <p:cNvSpPr txBox="1"/>
-            <p:nvPr/>
-          </p:nvSpPr>
-          <p:spPr>
-            <a:xfrm>
-              <a:off x="4035372" y="3516528"/>
-              <a:ext cx="923203" cy="374709"/>
-            </a:xfrm>
-            <a:prstGeom prst="rect">
-              <a:avLst/>
-            </a:prstGeom>
-            <a:noFill/>
-          </p:spPr>
-          <p:txBody>
-            <a:bodyPr wrap="none" rtlCol="0">
-              <a:spAutoFit/>
-            </a:bodyPr>
-            <a:lstStyle/>
-            <a:p>
-              <a:pPr algn="ctr"/>
-              <a:r>
-                <a:rPr lang="en-US" sz="1701" dirty="0">
-                  <a:solidFill>
-                    <a:schemeClr val="bg1">
-                      <a:lumMod val="75000"/>
-                    </a:schemeClr>
-                  </a:solidFill>
-                </a:rPr>
-                <a:t>WinSCP</a:t>
-              </a:r>
-            </a:p>
-          </p:txBody>
-        </p:sp>
-        <p:sp>
-          <p:nvSpPr>
-            <p:cNvPr id="36" name="TextBox 35">
-              <a:extLst>
-                <a:ext uri="{FF2B5EF4-FFF2-40B4-BE49-F238E27FC236}">
-                  <a16:creationId xmlns:a16="http://schemas.microsoft.com/office/drawing/2014/main" id="{85A300FB-6D58-B27F-6D9F-7B7A42F8F6B6}"/>
-                </a:ext>
-              </a:extLst>
-            </p:cNvPr>
-            <p:cNvSpPr txBox="1"/>
-            <p:nvPr/>
-          </p:nvSpPr>
-          <p:spPr>
-            <a:xfrm>
-              <a:off x="3351707" y="3834612"/>
-              <a:ext cx="2290533" cy="282423"/>
-            </a:xfrm>
-            <a:prstGeom prst="rect">
-              <a:avLst/>
-            </a:prstGeom>
-            <a:noFill/>
-          </p:spPr>
-          <p:txBody>
-            <a:bodyPr wrap="none" rtlCol="0">
-              <a:spAutoFit/>
-            </a:bodyPr>
-            <a:lstStyle/>
-            <a:p>
-              <a:pPr algn="ctr"/>
-              <a:r>
-                <a:rPr lang="en-US" sz="1134" dirty="0">
-                  <a:solidFill>
-                    <a:schemeClr val="bg1">
-                      <a:lumMod val="75000"/>
-                    </a:schemeClr>
-                  </a:solidFill>
-                </a:rPr>
-                <a:t>(manual drag, no version control)</a:t>
-              </a:r>
-            </a:p>
-          </p:txBody>
-        </p:sp>
-        <p:sp>
-          <p:nvSpPr>
-            <p:cNvPr id="37" name="TextBox 36">
-              <a:extLst>
-                <a:ext uri="{FF2B5EF4-FFF2-40B4-BE49-F238E27FC236}">
-                  <a16:creationId xmlns:a16="http://schemas.microsoft.com/office/drawing/2014/main" id="{D69BCFD8-4DEF-C6BA-FAA2-AA93FD5E854E}"/>
-                </a:ext>
-              </a:extLst>
-            </p:cNvPr>
-            <p:cNvSpPr txBox="1"/>
-            <p:nvPr/>
-          </p:nvSpPr>
-          <p:spPr>
-            <a:xfrm rot="2700000">
-              <a:off x="5561922" y="2855358"/>
-              <a:ext cx="833291" cy="374709"/>
-            </a:xfrm>
-            <a:prstGeom prst="rect">
-              <a:avLst/>
-            </a:prstGeom>
-            <a:noFill/>
-          </p:spPr>
-          <p:txBody>
-            <a:bodyPr wrap="none" rtlCol="0">
-              <a:spAutoFit/>
-            </a:bodyPr>
-            <a:lstStyle/>
-            <a:p>
-              <a:r>
-                <a:rPr lang="en-US" sz="1701" dirty="0"/>
-                <a:t>git pull</a:t>
-              </a:r>
-            </a:p>
-          </p:txBody>
-        </p:sp>
-        <p:sp>
-          <p:nvSpPr>
-            <p:cNvPr id="38" name="TextBox 37">
-              <a:extLst>
-                <a:ext uri="{FF2B5EF4-FFF2-40B4-BE49-F238E27FC236}">
-                  <a16:creationId xmlns:a16="http://schemas.microsoft.com/office/drawing/2014/main" id="{AA03FDB9-DC2B-D1B2-D1EB-894AF5C1979E}"/>
-                </a:ext>
-              </a:extLst>
-            </p:cNvPr>
-            <p:cNvSpPr txBox="1"/>
-            <p:nvPr/>
-          </p:nvSpPr>
-          <p:spPr>
-            <a:xfrm rot="18900000">
-              <a:off x="2542260" y="2855359"/>
-              <a:ext cx="938470" cy="374709"/>
-            </a:xfrm>
-            <a:prstGeom prst="rect">
-              <a:avLst/>
-            </a:prstGeom>
-            <a:noFill/>
-          </p:spPr>
-          <p:txBody>
-            <a:bodyPr wrap="none" rtlCol="0">
-              <a:spAutoFit/>
-            </a:bodyPr>
-            <a:lstStyle/>
-            <a:p>
-              <a:r>
-                <a:rPr lang="en-US" sz="1701" dirty="0"/>
-                <a:t>git push</a:t>
-              </a:r>
-            </a:p>
-          </p:txBody>
-        </p:sp>
-        <p:sp>
-          <p:nvSpPr>
-            <p:cNvPr id="39" name="TextBox 38">
-              <a:extLst>
-                <a:ext uri="{FF2B5EF4-FFF2-40B4-BE49-F238E27FC236}">
-                  <a16:creationId xmlns:a16="http://schemas.microsoft.com/office/drawing/2014/main" id="{0A0DF2FA-08FB-970C-1903-89F52ABF71C0}"/>
-                </a:ext>
-              </a:extLst>
-            </p:cNvPr>
-            <p:cNvSpPr txBox="1"/>
-            <p:nvPr/>
-          </p:nvSpPr>
-          <p:spPr>
-            <a:xfrm>
-              <a:off x="756287" y="1061422"/>
-              <a:ext cx="3682836" cy="374709"/>
-            </a:xfrm>
-            <a:prstGeom prst="rect">
-              <a:avLst/>
-            </a:prstGeom>
-            <a:noFill/>
-          </p:spPr>
-          <p:txBody>
-            <a:bodyPr wrap="none" rtlCol="0">
-              <a:spAutoFit/>
-            </a:bodyPr>
-            <a:lstStyle/>
-            <a:p>
-              <a:r>
-                <a:rPr lang="en-US" sz="1701" b="1" dirty="0"/>
-                <a:t>MIT Athena CV Deployment Pipeline</a:t>
-              </a:r>
-            </a:p>
-          </p:txBody>
-        </p:sp>
-        <p:pic>
-          <p:nvPicPr>
-            <p:cNvPr id="7" name="Picture 6">
-              <a:extLst>
-                <a:ext uri="{FF2B5EF4-FFF2-40B4-BE49-F238E27FC236}">
-                  <a16:creationId xmlns:a16="http://schemas.microsoft.com/office/drawing/2014/main" id="{C6355D75-089C-8E58-451A-C0253DAEB89E}"/>
-                </a:ext>
-              </a:extLst>
-            </p:cNvPr>
-            <p:cNvPicPr>
-              <a:picLocks noChangeAspect="1"/>
-            </p:cNvPicPr>
-            <p:nvPr/>
-          </p:nvPicPr>
-          <p:blipFill>
-            <a:blip r:embed="rId5">
-              <a:extLst>
-                <a:ext uri="{28A0092B-C50C-407E-A947-70E740481C1C}">
-                  <a14:useLocalDpi xmlns:a14="http://schemas.microsoft.com/office/drawing/2010/main" val="0"/>
-                </a:ext>
-              </a:extLst>
-            </a:blip>
-            <a:stretch>
-              <a:fillRect/>
-            </a:stretch>
-          </p:blipFill>
-          <p:spPr>
-            <a:xfrm>
-              <a:off x="1637947" y="2796528"/>
-              <a:ext cx="720000" cy="720000"/>
-            </a:xfrm>
-            <a:prstGeom prst="rect">
-              <a:avLst/>
-            </a:prstGeom>
-          </p:spPr>
-        </p:pic>
-      </p:grpSp>
-      <p:sp>
-        <p:nvSpPr>
-          <p:cNvPr id="2" name="Date Placeholder 1">
-            <a:extLst>
-              <a:ext uri="{FF2B5EF4-FFF2-40B4-BE49-F238E27FC236}">
-                <a16:creationId xmlns:a16="http://schemas.microsoft.com/office/drawing/2014/main" id="{A88495AD-AD71-B31B-8E47-DBEE3C97E134}"/>
-              </a:ext>
-            </a:extLst>
-          </p:cNvPr>
-          <p:cNvSpPr>
-            <a:spLocks noGrp="1"/>
-          </p:cNvSpPr>
-          <p:nvPr>
-            <p:ph type="dt" sz="half" idx="10"/>
-          </p:nvPr>
-        </p:nvSpPr>
-        <p:spPr/>
-        <p:txBody>
-          <a:bodyPr/>
-          <a:lstStyle/>
-          <a:p>
-            <a:fld id="{66D9F0A0-8D92-457F-9C02-E7D242CA7398}" type="datetime1">
-              <a:rPr lang="en-US" smtClean="0"/>
-              <a:t>2026-05-30</a:t>
-            </a:fld>
-            <a:endParaRPr lang="en-US"/>
-          </a:p>
-        </p:txBody>
-      </p:sp>
-      <p:sp>
-        <p:nvSpPr>
-          <p:cNvPr id="6" name="Footer Placeholder 5">
-            <a:extLst>
-              <a:ext uri="{FF2B5EF4-FFF2-40B4-BE49-F238E27FC236}">
-                <a16:creationId xmlns:a16="http://schemas.microsoft.com/office/drawing/2014/main" id="{0D5401D2-D4C4-B9DA-802C-9F714AEBFACB}"/>
-              </a:ext>
-            </a:extLst>
-          </p:cNvPr>
-          <p:cNvSpPr>
-            <a:spLocks noGrp="1"/>
-          </p:cNvSpPr>
-          <p:nvPr>
-            <p:ph type="ftr" sz="quarter" idx="11"/>
-          </p:nvPr>
-        </p:nvSpPr>
-        <p:spPr/>
-        <p:txBody>
-          <a:bodyPr/>
-          <a:lstStyle/>
-          <a:p>
-            <a:r>
-              <a:rPr lang="en-US"/>
-              <a:t>your-name@your.institute.edu</a:t>
-            </a:r>
-          </a:p>
-        </p:txBody>
-      </p:sp>
-      <p:sp>
-        <p:nvSpPr>
-          <p:cNvPr id="9" name="Slide Number Placeholder 8">
-            <a:extLst>
-              <a:ext uri="{FF2B5EF4-FFF2-40B4-BE49-F238E27FC236}">
-                <a16:creationId xmlns:a16="http://schemas.microsoft.com/office/drawing/2014/main" id="{9F34F312-744C-B402-40A5-0ED8E8404E97}"/>
-              </a:ext>
-            </a:extLst>
-          </p:cNvPr>
-          <p:cNvSpPr>
-            <a:spLocks noGrp="1"/>
-          </p:cNvSpPr>
-          <p:nvPr>
-            <p:ph type="sldNum" sz="quarter" idx="12"/>
-          </p:nvPr>
-        </p:nvSpPr>
-        <p:spPr/>
-        <p:txBody>
-          <a:bodyPr/>
-          <a:lstStyle/>
-          <a:p>
-            <a:fld id="{BE208443-9971-4CF7-AC11-FCF956BB598F}" type="slidenum">
-              <a:rPr lang="en-US" smtClean="0"/>
-              <a:t>1</a:t>
-            </a:fld>
-            <a:endParaRPr lang="en-US"/>
-          </a:p>
-        </p:txBody>
-      </p:sp>
-      <p:grpSp>
-        <p:nvGrpSpPr>
-          <p:cNvPr id="10" name="Group 9">
-            <a:extLst>
-              <a:ext uri="{FF2B5EF4-FFF2-40B4-BE49-F238E27FC236}">
-                <a16:creationId xmlns:a16="http://schemas.microsoft.com/office/drawing/2014/main" id="{0F4EF88D-4DD9-06A9-2EB7-ADC6E15108FD}"/>
-              </a:ext>
-            </a:extLst>
-          </p:cNvPr>
-          <p:cNvGrpSpPr/>
-          <p:nvPr/>
-        </p:nvGrpSpPr>
-        <p:grpSpPr>
-          <a:xfrm>
-            <a:off x="-10800000" y="-7200000"/>
-            <a:ext cx="33120000" cy="23040000"/>
-            <a:chOff x="-10800000" y="-7200000"/>
-            <a:chExt cx="33120000" cy="23040000"/>
-          </a:xfrm>
-        </p:grpSpPr>
-        <p:sp>
-          <p:nvSpPr>
-            <p:cNvPr id="11" name="Oval 10">
-              <a:extLst>
-                <a:ext uri="{FF2B5EF4-FFF2-40B4-BE49-F238E27FC236}">
-                  <a16:creationId xmlns:a16="http://schemas.microsoft.com/office/drawing/2014/main" id="{96924D1E-339B-BF3B-2F1E-B737EE51B290}"/>
-                </a:ext>
-              </a:extLst>
-            </p:cNvPr>
-            <p:cNvSpPr/>
-            <p:nvPr/>
-          </p:nvSpPr>
-          <p:spPr>
-            <a:xfrm>
-              <a:off x="-10800000" y="-7200000"/>
-              <a:ext cx="1440000" cy="1440000"/>
-            </a:xfrm>
-            <a:prstGeom prst="ellipse">
-              <a:avLst/>
-            </a:prstGeom>
-            <a:solidFill>
-              <a:srgbClr val="48DA9B"/>
-            </a:solidFill>
-            <a:ln>
-              <a:noFill/>
-            </a:ln>
-          </p:spPr>
-          <p:style>
-            <a:lnRef idx="2">
-              <a:schemeClr val="accent1">
-                <a:shade val="50000"/>
-              </a:schemeClr>
-            </a:lnRef>
-            <a:fillRef idx="1">
-              <a:schemeClr val="accent1"/>
-            </a:fillRef>
-            <a:effectRef idx="0">
-              <a:schemeClr val="accent1"/>
-            </a:effectRef>
-            <a:fontRef idx="minor">
-              <a:schemeClr val="lt1"/>
-            </a:fontRef>
-          </p:style>
-          <p:txBody>
-            <a:bodyPr rtlCol="0" anchor="ctr"/>
-            <a:lstStyle/>
-            <a:p>
-              <a:pPr algn="ctr"/>
-              <a:endParaRPr lang="en-US" sz="1607"/>
-            </a:p>
-          </p:txBody>
-        </p:sp>
-        <p:sp>
-          <p:nvSpPr>
-            <p:cNvPr id="12" name="Oval 11">
-              <a:extLst>
-                <a:ext uri="{FF2B5EF4-FFF2-40B4-BE49-F238E27FC236}">
-                  <a16:creationId xmlns:a16="http://schemas.microsoft.com/office/drawing/2014/main" id="{E02692D6-786C-AB51-0820-8447417789CC}"/>
-                </a:ext>
-              </a:extLst>
-            </p:cNvPr>
-            <p:cNvSpPr/>
-            <p:nvPr/>
-          </p:nvSpPr>
-          <p:spPr>
-            <a:xfrm>
-              <a:off x="20880000" y="-7200000"/>
-              <a:ext cx="1440000" cy="1440000"/>
-            </a:xfrm>
-            <a:prstGeom prst="ellipse">
-              <a:avLst/>
-            </a:prstGeom>
-            <a:solidFill>
-              <a:srgbClr val="29C782"/>
-            </a:solidFill>
-            <a:ln>
-              <a:noFill/>
-            </a:ln>
-          </p:spPr>
-          <p:style>
-            <a:lnRef idx="2">
-              <a:schemeClr val="accent1">
-                <a:shade val="50000"/>
-              </a:schemeClr>
-            </a:lnRef>
-            <a:fillRef idx="1">
-              <a:schemeClr val="accent1"/>
-            </a:fillRef>
-            <a:effectRef idx="0">
-              <a:schemeClr val="accent1"/>
-            </a:effectRef>
-            <a:fontRef idx="minor">
-              <a:schemeClr val="lt1"/>
-            </a:fontRef>
-          </p:style>
-          <p:txBody>
-            <a:bodyPr rtlCol="0" anchor="ctr"/>
-            <a:lstStyle/>
-            <a:p>
-              <a:pPr algn="ctr"/>
-              <a:endParaRPr lang="en-US" sz="1607"/>
-            </a:p>
-          </p:txBody>
-        </p:sp>
-        <p:sp>
-          <p:nvSpPr>
-            <p:cNvPr id="13" name="Oval 12">
-              <a:extLst>
-                <a:ext uri="{FF2B5EF4-FFF2-40B4-BE49-F238E27FC236}">
-                  <a16:creationId xmlns:a16="http://schemas.microsoft.com/office/drawing/2014/main" id="{18089A5E-136E-6D83-A6CE-3A22AFEF47FA}"/>
-                </a:ext>
-              </a:extLst>
-            </p:cNvPr>
-            <p:cNvSpPr/>
-            <p:nvPr/>
-          </p:nvSpPr>
-          <p:spPr>
-            <a:xfrm>
-              <a:off x="-10800000" y="14400000"/>
-              <a:ext cx="1440000" cy="1440000"/>
-            </a:xfrm>
-            <a:prstGeom prst="ellipse">
-              <a:avLst/>
-            </a:prstGeom>
-            <a:solidFill>
-              <a:srgbClr val="0F7D6F"/>
-            </a:solidFill>
-            <a:ln>
-              <a:noFill/>
-            </a:ln>
-          </p:spPr>
-          <p:style>
-            <a:lnRef idx="2">
-              <a:schemeClr val="accent1">
-                <a:shade val="50000"/>
-              </a:schemeClr>
-            </a:lnRef>
-            <a:fillRef idx="1">
-              <a:schemeClr val="accent1"/>
-            </a:fillRef>
-            <a:effectRef idx="0">
-              <a:schemeClr val="accent1"/>
-            </a:effectRef>
-            <a:fontRef idx="minor">
-              <a:schemeClr val="lt1"/>
-            </a:fontRef>
-          </p:style>
-          <p:txBody>
-            <a:bodyPr rtlCol="0" anchor="ctr"/>
-            <a:lstStyle/>
-            <a:p>
-              <a:pPr algn="ctr"/>
-              <a:endParaRPr lang="en-US" sz="1607"/>
-            </a:p>
-          </p:txBody>
-        </p:sp>
-        <p:sp>
-          <p:nvSpPr>
-            <p:cNvPr id="14" name="Oval 13">
-              <a:extLst>
-                <a:ext uri="{FF2B5EF4-FFF2-40B4-BE49-F238E27FC236}">
-                  <a16:creationId xmlns:a16="http://schemas.microsoft.com/office/drawing/2014/main" id="{3D1FEB2F-6F3D-956D-85E9-335534C07C30}"/>
-                </a:ext>
-              </a:extLst>
-            </p:cNvPr>
-            <p:cNvSpPr/>
-            <p:nvPr/>
-          </p:nvSpPr>
-          <p:spPr>
-            <a:xfrm>
-              <a:off x="20880000" y="14400000"/>
-              <a:ext cx="1440000" cy="1440000"/>
-            </a:xfrm>
-            <a:prstGeom prst="ellipse">
-              <a:avLst/>
-            </a:prstGeom>
-            <a:solidFill>
-              <a:srgbClr val="0B5F52"/>
-            </a:solidFill>
-            <a:ln>
-              <a:noFill/>
-            </a:ln>
-          </p:spPr>
-          <p:style>
-            <a:lnRef idx="2">
-              <a:schemeClr val="accent1">
-                <a:shade val="50000"/>
-              </a:schemeClr>
-            </a:lnRef>
-            <a:fillRef idx="1">
-              <a:schemeClr val="accent1"/>
-            </a:fillRef>
-            <a:effectRef idx="0">
-              <a:schemeClr val="accent1"/>
-            </a:effectRef>
-            <a:fontRef idx="minor">
-              <a:schemeClr val="lt1"/>
-            </a:fontRef>
-          </p:style>
-          <p:txBody>
-            <a:bodyPr rtlCol="0" anchor="ctr"/>
-            <a:lstStyle/>
-            <a:p>
-              <a:pPr algn="ctr"/>
-              <a:endParaRPr lang="en-US" sz="1607"/>
-            </a:p>
-          </p:txBody>
-        </p:sp>
-        <p:sp>
-          <p:nvSpPr>
-            <p:cNvPr id="15" name="Oval 14">
-              <a:extLst>
-                <a:ext uri="{FF2B5EF4-FFF2-40B4-BE49-F238E27FC236}">
-                  <a16:creationId xmlns:a16="http://schemas.microsoft.com/office/drawing/2014/main" id="{F0A33C3C-C0C8-0E2A-7004-A4C1B05DBB63}"/>
-                </a:ext>
-              </a:extLst>
-            </p:cNvPr>
-            <p:cNvSpPr/>
-            <p:nvPr/>
-          </p:nvSpPr>
-          <p:spPr>
-            <a:xfrm>
-              <a:off x="5040000" y="-7200000"/>
-              <a:ext cx="1440000" cy="1440000"/>
-            </a:xfrm>
-            <a:prstGeom prst="ellipse">
-              <a:avLst/>
-            </a:prstGeom>
-            <a:solidFill>
-              <a:srgbClr val="E4E3E8"/>
-            </a:solidFill>
-            <a:ln>
-              <a:noFill/>
-            </a:ln>
-          </p:spPr>
-          <p:style>
-            <a:lnRef idx="2">
-              <a:schemeClr val="accent1">
-                <a:shade val="50000"/>
-              </a:schemeClr>
-            </a:lnRef>
-            <a:fillRef idx="1">
-              <a:schemeClr val="accent1"/>
-            </a:fillRef>
-            <a:effectRef idx="0">
-              <a:schemeClr val="accent1"/>
-            </a:effectRef>
-            <a:fontRef idx="minor">
-              <a:schemeClr val="lt1"/>
-            </a:fontRef>
-          </p:style>
-          <p:txBody>
-            <a:bodyPr rtlCol="0" anchor="ctr"/>
-            <a:lstStyle/>
-            <a:p>
-              <a:pPr algn="ctr"/>
-              <a:endParaRPr lang="en-US" sz="1607"/>
-            </a:p>
-          </p:txBody>
-        </p:sp>
-        <p:sp>
-          <p:nvSpPr>
-            <p:cNvPr id="16" name="Oval 15">
-              <a:extLst>
-                <a:ext uri="{FF2B5EF4-FFF2-40B4-BE49-F238E27FC236}">
-                  <a16:creationId xmlns:a16="http://schemas.microsoft.com/office/drawing/2014/main" id="{438BFE0C-3D37-E28C-F433-85D3C84C30CF}"/>
-                </a:ext>
-              </a:extLst>
-            </p:cNvPr>
-            <p:cNvSpPr/>
-            <p:nvPr/>
-          </p:nvSpPr>
-          <p:spPr>
-            <a:xfrm>
-              <a:off x="5040000" y="14400000"/>
-              <a:ext cx="1440000" cy="1440000"/>
-            </a:xfrm>
-            <a:prstGeom prst="ellipse">
-              <a:avLst/>
-            </a:prstGeom>
-            <a:solidFill>
-              <a:srgbClr val="2B2B30"/>
-            </a:solidFill>
-            <a:ln>
-              <a:noFill/>
-            </a:ln>
-          </p:spPr>
-          <p:style>
-            <a:lnRef idx="2">
-              <a:schemeClr val="accent1">
-                <a:shade val="50000"/>
-              </a:schemeClr>
-            </a:lnRef>
-            <a:fillRef idx="1">
-              <a:schemeClr val="accent1"/>
-            </a:fillRef>
-            <a:effectRef idx="0">
-              <a:schemeClr val="accent1"/>
-            </a:effectRef>
-            <a:fontRef idx="minor">
-              <a:schemeClr val="lt1"/>
-            </a:fontRef>
-          </p:style>
-          <p:txBody>
-            <a:bodyPr rtlCol="0" anchor="ctr"/>
-            <a:lstStyle/>
-            <a:p>
-              <a:pPr algn="ctr"/>
-              <a:endParaRPr lang="en-US" sz="1607"/>
-            </a:p>
-          </p:txBody>
-        </p:sp>
-      </p:grpSp>
-    </p:spTree>
-    <p:extLst>
-      <p:ext uri="{BB962C8B-B14F-4D97-AF65-F5344CB8AC3E}">
-        <p14:creationId xmlns:p14="http://schemas.microsoft.com/office/powerpoint/2010/main" val="1957021783"/>
-      </p:ext>
-    </p:extLst>
-  </p:cSld>
-  <p:clrMapOvr>
-    <a:masterClrMapping/>
-  </p:clrMapOvr>
-</p:sld>
-</file>
-
-<file path=ppt/slides/slide2.xml><?xml version="1.0" encoding="utf-8"?>
-<p:sld xmlns:a="http://schemas.openxmlformats.org/drawingml/2006/main" xmlns:r="http://schemas.openxmlformats.org/officeDocument/2006/relationships" xmlns:p="http://schemas.openxmlformats.org/presentationml/2006/main">
-  <p:cSld>
     <p:bg>
       <p:bgPr>
         <a:solidFill>
@@ -4785,98 +3536,12 @@
           <a:chExt cx="0" cy="0"/>
         </a:xfrm>
       </p:grpSpPr>
-      <p:sp>
-        <p:nvSpPr>
-          <p:cNvPr id="7" name="Date Placeholder 6">
+      <p:grpSp>
+        <p:nvGrpSpPr>
+          <p:cNvPr id="8" name="Group 7">
             <a:extLst>
               <a:ext uri="{FF2B5EF4-FFF2-40B4-BE49-F238E27FC236}">
-                <a16:creationId xmlns:a16="http://schemas.microsoft.com/office/drawing/2014/main" id="{FACF42D4-A8AE-1F6A-3926-33FE4A14C379}"/>
-              </a:ext>
-            </a:extLst>
-          </p:cNvPr>
-          <p:cNvSpPr>
-            <a:spLocks noGrp="1"/>
-          </p:cNvSpPr>
-          <p:nvPr>
-            <p:ph type="dt" sz="half" idx="10"/>
-          </p:nvPr>
-        </p:nvSpPr>
-        <p:spPr/>
-        <p:txBody>
-          <a:bodyPr/>
-          <a:lstStyle/>
-          <a:p>
-            <a:fld id="{BD71CCD9-8406-4FA8-9511-10DB39F06237}" type="datetime1">
-              <a:rPr lang="en-US" smtClean="0"/>
-              <a:t>2026-05-30</a:t>
-            </a:fld>
-            <a:endParaRPr lang="en-US"/>
-          </a:p>
-        </p:txBody>
-      </p:sp>
-      <p:sp>
-        <p:nvSpPr>
-          <p:cNvPr id="12" name="Footer Placeholder 11">
-            <a:extLst>
-              <a:ext uri="{FF2B5EF4-FFF2-40B4-BE49-F238E27FC236}">
-                <a16:creationId xmlns:a16="http://schemas.microsoft.com/office/drawing/2014/main" id="{6DA83CE2-FB71-201E-E824-04590EB02C13}"/>
-              </a:ext>
-            </a:extLst>
-          </p:cNvPr>
-          <p:cNvSpPr>
-            <a:spLocks noGrp="1"/>
-          </p:cNvSpPr>
-          <p:nvPr>
-            <p:ph type="ftr" sz="quarter" idx="11"/>
-          </p:nvPr>
-        </p:nvSpPr>
-        <p:spPr/>
-        <p:txBody>
-          <a:bodyPr/>
-          <a:lstStyle/>
-          <a:p>
-            <a:r>
-              <a:rPr lang="en-US"/>
-              <a:t>your-name@your.institute.edu</a:t>
-            </a:r>
-          </a:p>
-        </p:txBody>
-      </p:sp>
-      <p:sp>
-        <p:nvSpPr>
-          <p:cNvPr id="13" name="Slide Number Placeholder 12">
-            <a:extLst>
-              <a:ext uri="{FF2B5EF4-FFF2-40B4-BE49-F238E27FC236}">
-                <a16:creationId xmlns:a16="http://schemas.microsoft.com/office/drawing/2014/main" id="{E375E2EA-1E5B-537E-9569-916BFEB82D73}"/>
-              </a:ext>
-            </a:extLst>
-          </p:cNvPr>
-          <p:cNvSpPr>
-            <a:spLocks noGrp="1"/>
-          </p:cNvSpPr>
-          <p:nvPr>
-            <p:ph type="sldNum" sz="quarter" idx="12"/>
-          </p:nvPr>
-        </p:nvSpPr>
-        <p:spPr/>
-        <p:txBody>
-          <a:bodyPr/>
-          <a:lstStyle/>
-          <a:p>
-            <a:fld id="{BE208443-9971-4CF7-AC11-FCF956BB598F}" type="slidenum">
-              <a:rPr lang="en-US" smtClean="0"/>
-              <a:t>2</a:t>
-            </a:fld>
-            <a:endParaRPr lang="en-US"/>
-          </a:p>
-        </p:txBody>
-      </p:sp>
-      <p:grpSp>
-        <p:nvGrpSpPr>
-          <p:cNvPr id="17" name="Group 16">
-            <a:extLst>
-              <a:ext uri="{FF2B5EF4-FFF2-40B4-BE49-F238E27FC236}">
-                <a16:creationId xmlns:a16="http://schemas.microsoft.com/office/drawing/2014/main" id="{D471EF34-CD98-BB53-3D23-08FA1CCFA7C7}"/>
+                <a16:creationId xmlns:a16="http://schemas.microsoft.com/office/drawing/2014/main" id="{26F21685-7756-545B-9227-698ADB1338AC}"/>
               </a:ext>
             </a:extLst>
           </p:cNvPr>
@@ -4885,10 +3550,343 @@
         </p:nvGrpSpPr>
         <p:grpSpPr>
           <a:xfrm>
-            <a:off x="0" y="882322"/>
-            <a:ext cx="11520488" cy="6480000"/>
-            <a:chOff x="0" y="882322"/>
-            <a:chExt cx="11520488" cy="6480000"/>
+            <a:off x="-10800000" y="-7200000"/>
+            <a:ext cx="33120000" cy="23040000"/>
+            <a:chOff x="-10800000" y="-7200000"/>
+            <a:chExt cx="33120000" cy="23040000"/>
+          </a:xfrm>
+        </p:grpSpPr>
+        <p:sp>
+          <p:nvSpPr>
+            <p:cNvPr id="9" name="Oval 8">
+              <a:extLst>
+                <a:ext uri="{FF2B5EF4-FFF2-40B4-BE49-F238E27FC236}">
+                  <a16:creationId xmlns:a16="http://schemas.microsoft.com/office/drawing/2014/main" id="{FE2E22A1-6C22-A741-86AD-2B384DBBE47D}"/>
+                </a:ext>
+              </a:extLst>
+            </p:cNvPr>
+            <p:cNvSpPr/>
+            <p:nvPr/>
+          </p:nvSpPr>
+          <p:spPr>
+            <a:xfrm>
+              <a:off x="-10800000" y="-7200000"/>
+              <a:ext cx="1440000" cy="1440000"/>
+            </a:xfrm>
+            <a:prstGeom prst="ellipse">
+              <a:avLst/>
+            </a:prstGeom>
+            <a:solidFill>
+              <a:srgbClr val="48DA9B"/>
+            </a:solidFill>
+            <a:ln>
+              <a:noFill/>
+            </a:ln>
+          </p:spPr>
+          <p:style>
+            <a:lnRef idx="2">
+              <a:schemeClr val="accent1">
+                <a:shade val="50000"/>
+              </a:schemeClr>
+            </a:lnRef>
+            <a:fillRef idx="1">
+              <a:schemeClr val="accent1"/>
+            </a:fillRef>
+            <a:effectRef idx="0">
+              <a:schemeClr val="accent1"/>
+            </a:effectRef>
+            <a:fontRef idx="minor">
+              <a:schemeClr val="lt1"/>
+            </a:fontRef>
+          </p:style>
+          <p:txBody>
+            <a:bodyPr rtlCol="0" anchor="ctr"/>
+            <a:lstStyle/>
+            <a:p>
+              <a:pPr algn="ctr"/>
+              <a:endParaRPr lang="en-US" sz="1607"/>
+            </a:p>
+          </p:txBody>
+        </p:sp>
+        <p:sp>
+          <p:nvSpPr>
+            <p:cNvPr id="10" name="Oval 9">
+              <a:extLst>
+                <a:ext uri="{FF2B5EF4-FFF2-40B4-BE49-F238E27FC236}">
+                  <a16:creationId xmlns:a16="http://schemas.microsoft.com/office/drawing/2014/main" id="{7319A108-241C-63E7-2DD1-E90E54F66275}"/>
+                </a:ext>
+              </a:extLst>
+            </p:cNvPr>
+            <p:cNvSpPr/>
+            <p:nvPr/>
+          </p:nvSpPr>
+          <p:spPr>
+            <a:xfrm>
+              <a:off x="20880000" y="-7200000"/>
+              <a:ext cx="1440000" cy="1440000"/>
+            </a:xfrm>
+            <a:prstGeom prst="ellipse">
+              <a:avLst/>
+            </a:prstGeom>
+            <a:solidFill>
+              <a:srgbClr val="29C782"/>
+            </a:solidFill>
+            <a:ln>
+              <a:noFill/>
+            </a:ln>
+          </p:spPr>
+          <p:style>
+            <a:lnRef idx="2">
+              <a:schemeClr val="accent1">
+                <a:shade val="50000"/>
+              </a:schemeClr>
+            </a:lnRef>
+            <a:fillRef idx="1">
+              <a:schemeClr val="accent1"/>
+            </a:fillRef>
+            <a:effectRef idx="0">
+              <a:schemeClr val="accent1"/>
+            </a:effectRef>
+            <a:fontRef idx="minor">
+              <a:schemeClr val="lt1"/>
+            </a:fontRef>
+          </p:style>
+          <p:txBody>
+            <a:bodyPr rtlCol="0" anchor="ctr"/>
+            <a:lstStyle/>
+            <a:p>
+              <a:pPr algn="ctr"/>
+              <a:endParaRPr lang="en-US" sz="1607"/>
+            </a:p>
+          </p:txBody>
+        </p:sp>
+        <p:sp>
+          <p:nvSpPr>
+            <p:cNvPr id="11" name="Oval 10">
+              <a:extLst>
+                <a:ext uri="{FF2B5EF4-FFF2-40B4-BE49-F238E27FC236}">
+                  <a16:creationId xmlns:a16="http://schemas.microsoft.com/office/drawing/2014/main" id="{1E5119E2-322D-0136-E4A4-09A1D4E0ED4B}"/>
+                </a:ext>
+              </a:extLst>
+            </p:cNvPr>
+            <p:cNvSpPr/>
+            <p:nvPr/>
+          </p:nvSpPr>
+          <p:spPr>
+            <a:xfrm>
+              <a:off x="-10800000" y="14400000"/>
+              <a:ext cx="1440000" cy="1440000"/>
+            </a:xfrm>
+            <a:prstGeom prst="ellipse">
+              <a:avLst/>
+            </a:prstGeom>
+            <a:solidFill>
+              <a:srgbClr val="0F7D6F"/>
+            </a:solidFill>
+            <a:ln>
+              <a:noFill/>
+            </a:ln>
+          </p:spPr>
+          <p:style>
+            <a:lnRef idx="2">
+              <a:schemeClr val="accent1">
+                <a:shade val="50000"/>
+              </a:schemeClr>
+            </a:lnRef>
+            <a:fillRef idx="1">
+              <a:schemeClr val="accent1"/>
+            </a:fillRef>
+            <a:effectRef idx="0">
+              <a:schemeClr val="accent1"/>
+            </a:effectRef>
+            <a:fontRef idx="minor">
+              <a:schemeClr val="lt1"/>
+            </a:fontRef>
+          </p:style>
+          <p:txBody>
+            <a:bodyPr rtlCol="0" anchor="ctr"/>
+            <a:lstStyle/>
+            <a:p>
+              <a:pPr algn="ctr"/>
+              <a:endParaRPr lang="en-US" sz="1607"/>
+            </a:p>
+          </p:txBody>
+        </p:sp>
+        <p:sp>
+          <p:nvSpPr>
+            <p:cNvPr id="14" name="Oval 13">
+              <a:extLst>
+                <a:ext uri="{FF2B5EF4-FFF2-40B4-BE49-F238E27FC236}">
+                  <a16:creationId xmlns:a16="http://schemas.microsoft.com/office/drawing/2014/main" id="{901DB422-DEAE-A92D-33E2-52E5CDC712AD}"/>
+                </a:ext>
+              </a:extLst>
+            </p:cNvPr>
+            <p:cNvSpPr/>
+            <p:nvPr/>
+          </p:nvSpPr>
+          <p:spPr>
+            <a:xfrm>
+              <a:off x="20880000" y="14400000"/>
+              <a:ext cx="1440000" cy="1440000"/>
+            </a:xfrm>
+            <a:prstGeom prst="ellipse">
+              <a:avLst/>
+            </a:prstGeom>
+            <a:solidFill>
+              <a:srgbClr val="0B5F52"/>
+            </a:solidFill>
+            <a:ln>
+              <a:noFill/>
+            </a:ln>
+          </p:spPr>
+          <p:style>
+            <a:lnRef idx="2">
+              <a:schemeClr val="accent1">
+                <a:shade val="50000"/>
+              </a:schemeClr>
+            </a:lnRef>
+            <a:fillRef idx="1">
+              <a:schemeClr val="accent1"/>
+            </a:fillRef>
+            <a:effectRef idx="0">
+              <a:schemeClr val="accent1"/>
+            </a:effectRef>
+            <a:fontRef idx="minor">
+              <a:schemeClr val="lt1"/>
+            </a:fontRef>
+          </p:style>
+          <p:txBody>
+            <a:bodyPr rtlCol="0" anchor="ctr"/>
+            <a:lstStyle/>
+            <a:p>
+              <a:pPr algn="ctr"/>
+              <a:endParaRPr lang="en-US" sz="1607"/>
+            </a:p>
+          </p:txBody>
+        </p:sp>
+        <p:sp>
+          <p:nvSpPr>
+            <p:cNvPr id="15" name="Oval 14">
+              <a:extLst>
+                <a:ext uri="{FF2B5EF4-FFF2-40B4-BE49-F238E27FC236}">
+                  <a16:creationId xmlns:a16="http://schemas.microsoft.com/office/drawing/2014/main" id="{A1DF03A8-F2AB-0B08-94F0-0BEE333F292D}"/>
+                </a:ext>
+              </a:extLst>
+            </p:cNvPr>
+            <p:cNvSpPr/>
+            <p:nvPr/>
+          </p:nvSpPr>
+          <p:spPr>
+            <a:xfrm>
+              <a:off x="5040000" y="-7200000"/>
+              <a:ext cx="1440000" cy="1440000"/>
+            </a:xfrm>
+            <a:prstGeom prst="ellipse">
+              <a:avLst/>
+            </a:prstGeom>
+            <a:solidFill>
+              <a:srgbClr val="E4E3E8"/>
+            </a:solidFill>
+            <a:ln>
+              <a:noFill/>
+            </a:ln>
+          </p:spPr>
+          <p:style>
+            <a:lnRef idx="2">
+              <a:schemeClr val="accent1">
+                <a:shade val="50000"/>
+              </a:schemeClr>
+            </a:lnRef>
+            <a:fillRef idx="1">
+              <a:schemeClr val="accent1"/>
+            </a:fillRef>
+            <a:effectRef idx="0">
+              <a:schemeClr val="accent1"/>
+            </a:effectRef>
+            <a:fontRef idx="minor">
+              <a:schemeClr val="lt1"/>
+            </a:fontRef>
+          </p:style>
+          <p:txBody>
+            <a:bodyPr rtlCol="0" anchor="ctr"/>
+            <a:lstStyle/>
+            <a:p>
+              <a:pPr algn="ctr"/>
+              <a:endParaRPr lang="en-US" sz="1607"/>
+            </a:p>
+          </p:txBody>
+        </p:sp>
+        <p:sp>
+          <p:nvSpPr>
+            <p:cNvPr id="16" name="Oval 15">
+              <a:extLst>
+                <a:ext uri="{FF2B5EF4-FFF2-40B4-BE49-F238E27FC236}">
+                  <a16:creationId xmlns:a16="http://schemas.microsoft.com/office/drawing/2014/main" id="{87B96A9F-D9E6-76FE-EDC6-ADBA65FD8C76}"/>
+                </a:ext>
+              </a:extLst>
+            </p:cNvPr>
+            <p:cNvSpPr/>
+            <p:nvPr/>
+          </p:nvSpPr>
+          <p:spPr>
+            <a:xfrm>
+              <a:off x="5040000" y="14400000"/>
+              <a:ext cx="1440000" cy="1440000"/>
+            </a:xfrm>
+            <a:prstGeom prst="ellipse">
+              <a:avLst/>
+            </a:prstGeom>
+            <a:solidFill>
+              <a:srgbClr val="2B2B30"/>
+            </a:solidFill>
+            <a:ln>
+              <a:noFill/>
+            </a:ln>
+          </p:spPr>
+          <p:style>
+            <a:lnRef idx="2">
+              <a:schemeClr val="accent1">
+                <a:shade val="50000"/>
+              </a:schemeClr>
+            </a:lnRef>
+            <a:fillRef idx="1">
+              <a:schemeClr val="accent1"/>
+            </a:fillRef>
+            <a:effectRef idx="0">
+              <a:schemeClr val="accent1"/>
+            </a:effectRef>
+            <a:fontRef idx="minor">
+              <a:schemeClr val="lt1"/>
+            </a:fontRef>
+          </p:style>
+          <p:txBody>
+            <a:bodyPr rtlCol="0" anchor="ctr"/>
+            <a:lstStyle/>
+            <a:p>
+              <a:pPr algn="ctr"/>
+              <a:endParaRPr lang="en-US" sz="1607"/>
+            </a:p>
+          </p:txBody>
+        </p:sp>
+      </p:grpSp>
+      <p:grpSp>
+        <p:nvGrpSpPr>
+          <p:cNvPr id="23" name="Group 22">
+            <a:extLst>
+              <a:ext uri="{FF2B5EF4-FFF2-40B4-BE49-F238E27FC236}">
+                <a16:creationId xmlns:a16="http://schemas.microsoft.com/office/drawing/2014/main" id="{7204924E-1820-B149-7B18-A69A799F7B9A}"/>
+              </a:ext>
+            </a:extLst>
+          </p:cNvPr>
+          <p:cNvGrpSpPr/>
+          <p:nvPr/>
+        </p:nvGrpSpPr>
+        <p:grpSpPr>
+          <a:xfrm>
+            <a:off x="0" y="0"/>
+            <a:ext cx="11520488" cy="11520000"/>
+            <a:chOff x="0" y="887036"/>
+            <a:chExt cx="11520488" cy="11520000"/>
           </a:xfrm>
         </p:grpSpPr>
         <p:sp>
@@ -4905,8 +3903,8 @@
           </p:nvSpPr>
           <p:spPr>
             <a:xfrm>
-              <a:off x="0" y="882322"/>
-              <a:ext cx="11520488" cy="6480000"/>
+              <a:off x="0" y="887036"/>
+              <a:ext cx="11520488" cy="11520000"/>
             </a:xfrm>
             <a:prstGeom prst="rect">
               <a:avLst/>
@@ -4939,7 +3937,7 @@
             <a:lstStyle/>
             <a:p>
               <a:pPr algn="ctr"/>
-              <a:endParaRPr lang="en-US" sz="1701"/>
+              <a:endParaRPr lang="en-US" sz="1701" dirty="0"/>
             </a:p>
           </p:txBody>
         </p:sp>
@@ -4957,7 +3955,7 @@
           </p:nvSpPr>
           <p:spPr>
             <a:xfrm>
-              <a:off x="5864520" y="2316222"/>
+              <a:off x="5864520" y="2697468"/>
               <a:ext cx="2765501" cy="354071"/>
             </a:xfrm>
             <a:prstGeom prst="rect">
@@ -4992,8 +3990,8 @@
           </p:nvSpPr>
           <p:spPr>
             <a:xfrm>
-              <a:off x="3172627" y="963236"/>
-              <a:ext cx="5175264" cy="523220"/>
+              <a:off x="1717326" y="1014641"/>
+              <a:ext cx="8085868" cy="892552"/>
             </a:xfrm>
             <a:prstGeom prst="rect">
               <a:avLst/>
@@ -5017,8 +4015,32 @@
                     </a:outerShdw>
                   </a:effectLst>
                 </a:rPr>
-                <a:t>Agentic Academic Site - Overview</a:t>
+                <a:t>Agentic Academic Site</a:t>
               </a:r>
+              <a:br>
+                <a:rPr lang="en-US" sz="2800" b="1" dirty="0">
+                  <a:effectLst>
+                    <a:outerShdw blurRad="50800" dist="38100" dir="2700000" algn="tl" rotWithShape="0">
+                      <a:prstClr val="black">
+                        <a:alpha val="40000"/>
+                      </a:prstClr>
+                    </a:outerShdw>
+                  </a:effectLst>
+                </a:rPr>
+              </a:br>
+              <a:r>
+                <a:rPr lang="en-US" sz="2400" i="1" dirty="0"/>
+                <a:t>Point your AI agent at it. Get your academic website in an hour.</a:t>
+              </a:r>
+              <a:endParaRPr lang="en-US" sz="2800" b="1" dirty="0">
+                <a:effectLst>
+                  <a:outerShdw blurRad="50800" dist="38100" dir="2700000" algn="tl" rotWithShape="0">
+                    <a:prstClr val="black">
+                      <a:alpha val="40000"/>
+                    </a:prstClr>
+                  </a:outerShdw>
+                </a:effectLst>
+              </a:endParaRPr>
             </a:p>
           </p:txBody>
         </p:sp>
@@ -5036,7 +4058,7 @@
           </p:nvSpPr>
           <p:spPr>
             <a:xfrm>
-              <a:off x="4425302" y="1616373"/>
+              <a:off x="4425302" y="1997619"/>
               <a:ext cx="2700000" cy="648000"/>
             </a:xfrm>
             <a:prstGeom prst="roundRect">
@@ -5120,6 +4142,1791 @@
           </p:nvCxnSpPr>
           <p:spPr>
             <a:xfrm rot="5400000">
+              <a:off x="5616244" y="2874503"/>
+              <a:ext cx="288000" cy="0"/>
+            </a:xfrm>
+            <a:prstGeom prst="straightConnector1">
+              <a:avLst/>
+            </a:prstGeom>
+            <a:ln w="38100">
+              <a:solidFill>
+                <a:schemeClr val="tx1">
+                  <a:lumMod val="50000"/>
+                  <a:lumOff val="50000"/>
+                </a:schemeClr>
+              </a:solidFill>
+              <a:tailEnd type="triangle"/>
+            </a:ln>
+          </p:spPr>
+          <p:style>
+            <a:lnRef idx="1">
+              <a:schemeClr val="accent1"/>
+            </a:lnRef>
+            <a:fillRef idx="0">
+              <a:schemeClr val="accent1"/>
+            </a:fillRef>
+            <a:effectRef idx="0">
+              <a:schemeClr val="accent1"/>
+            </a:effectRef>
+            <a:fontRef idx="minor">
+              <a:schemeClr val="tx1"/>
+            </a:fontRef>
+          </p:style>
+        </p:cxnSp>
+        <p:sp>
+          <p:nvSpPr>
+            <p:cNvPr id="1042" name="Rectangle: Rounded Corners 1041">
+              <a:extLst>
+                <a:ext uri="{FF2B5EF4-FFF2-40B4-BE49-F238E27FC236}">
+                  <a16:creationId xmlns:a16="http://schemas.microsoft.com/office/drawing/2014/main" id="{61F62A4A-56F2-68A7-E68F-72A3476F30CD}"/>
+                </a:ext>
+              </a:extLst>
+            </p:cNvPr>
+            <p:cNvSpPr/>
+            <p:nvPr/>
+          </p:nvSpPr>
+          <p:spPr>
+            <a:xfrm>
+              <a:off x="4425302" y="3122868"/>
+              <a:ext cx="2700000" cy="648000"/>
+            </a:xfrm>
+            <a:prstGeom prst="roundRect">
+              <a:avLst/>
+            </a:prstGeom>
+            <a:noFill/>
+            <a:ln w="50800">
+              <a:solidFill>
+                <a:srgbClr val="00B0F0">
+                  <a:alpha val="70000"/>
+                </a:srgbClr>
+              </a:solidFill>
+            </a:ln>
+          </p:spPr>
+          <p:style>
+            <a:lnRef idx="2">
+              <a:schemeClr val="accent1">
+                <a:shade val="15000"/>
+              </a:schemeClr>
+            </a:lnRef>
+            <a:fillRef idx="1">
+              <a:schemeClr val="accent1"/>
+            </a:fillRef>
+            <a:effectRef idx="0">
+              <a:schemeClr val="accent1"/>
+            </a:effectRef>
+            <a:fontRef idx="minor">
+              <a:schemeClr val="lt1"/>
+            </a:fontRef>
+          </p:style>
+          <p:txBody>
+            <a:bodyPr rtlCol="0" anchor="ctr"/>
+            <a:lstStyle/>
+            <a:p>
+              <a:pPr algn="ctr"/>
+              <a:r>
+                <a:rPr lang="en-US" altLang="zh-TW" b="1" dirty="0">
+                  <a:solidFill>
+                    <a:schemeClr val="tx1"/>
+                  </a:solidFill>
+                  <a:latin typeface="Liberation Mono" panose="02070409020205020404" pitchFamily="49" charset="0"/>
+                  <a:ea typeface="芫荽" pitchFamily="2" charset="-120"/>
+                  <a:cs typeface="Liberation Mono" panose="02070409020205020404" pitchFamily="49" charset="0"/>
+                </a:rPr>
+                <a:t>product-manager</a:t>
+              </a:r>
+            </a:p>
+            <a:p>
+              <a:pPr algn="ctr">
+                <a:lnSpc>
+                  <a:spcPts val="1512"/>
+                </a:lnSpc>
+              </a:pPr>
+              <a:r>
+                <a:rPr lang="en-US" sz="1600" dirty="0">
+                  <a:solidFill>
+                    <a:schemeClr val="tx1"/>
+                  </a:solidFill>
+                  <a:ea typeface="芫荽" pitchFamily="2" charset="-120"/>
+                  <a:cs typeface="芫荽" pitchFamily="2" charset="-120"/>
+                </a:rPr>
+                <a:t>Orchestrates the team.</a:t>
+              </a:r>
+            </a:p>
+          </p:txBody>
+        </p:sp>
+        <p:cxnSp>
+          <p:nvCxnSpPr>
+            <p:cNvPr id="1050" name="Straight Arrow Connector 1049">
+              <a:extLst>
+                <a:ext uri="{FF2B5EF4-FFF2-40B4-BE49-F238E27FC236}">
+                  <a16:creationId xmlns:a16="http://schemas.microsoft.com/office/drawing/2014/main" id="{3F043A0C-0DA7-12DA-8E9F-EF8C08F8EDD8}"/>
+                </a:ext>
+              </a:extLst>
+            </p:cNvPr>
+            <p:cNvCxnSpPr>
+              <a:cxnSpLocks/>
+            </p:cNvCxnSpPr>
+            <p:nvPr/>
+          </p:nvCxnSpPr>
+          <p:spPr>
+            <a:xfrm rot="5400000">
+              <a:off x="5616244" y="3998390"/>
+              <a:ext cx="288000" cy="0"/>
+            </a:xfrm>
+            <a:prstGeom prst="straightConnector1">
+              <a:avLst/>
+            </a:prstGeom>
+            <a:ln w="38100">
+              <a:solidFill>
+                <a:schemeClr val="tx1">
+                  <a:lumMod val="50000"/>
+                  <a:lumOff val="50000"/>
+                </a:schemeClr>
+              </a:solidFill>
+              <a:tailEnd type="triangle"/>
+            </a:ln>
+          </p:spPr>
+          <p:style>
+            <a:lnRef idx="1">
+              <a:schemeClr val="accent1"/>
+            </a:lnRef>
+            <a:fillRef idx="0">
+              <a:schemeClr val="accent1"/>
+            </a:fillRef>
+            <a:effectRef idx="0">
+              <a:schemeClr val="accent1"/>
+            </a:effectRef>
+            <a:fontRef idx="minor">
+              <a:schemeClr val="tx1"/>
+            </a:fontRef>
+          </p:style>
+        </p:cxnSp>
+        <p:cxnSp>
+          <p:nvCxnSpPr>
+            <p:cNvPr id="1052" name="Straight Arrow Connector 1051">
+              <a:extLst>
+                <a:ext uri="{FF2B5EF4-FFF2-40B4-BE49-F238E27FC236}">
+                  <a16:creationId xmlns:a16="http://schemas.microsoft.com/office/drawing/2014/main" id="{6DE930DD-EC4E-BD41-1714-21397F257CF4}"/>
+                </a:ext>
+              </a:extLst>
+            </p:cNvPr>
+            <p:cNvCxnSpPr>
+              <a:cxnSpLocks/>
+            </p:cNvCxnSpPr>
+            <p:nvPr/>
+          </p:nvCxnSpPr>
+          <p:spPr>
+            <a:xfrm>
+              <a:off x="4022857" y="3446868"/>
+              <a:ext cx="288000" cy="0"/>
+            </a:xfrm>
+            <a:prstGeom prst="straightConnector1">
+              <a:avLst/>
+            </a:prstGeom>
+            <a:ln w="38100">
+              <a:solidFill>
+                <a:schemeClr val="tx1">
+                  <a:lumMod val="50000"/>
+                  <a:lumOff val="50000"/>
+                </a:schemeClr>
+              </a:solidFill>
+              <a:tailEnd type="triangle"/>
+            </a:ln>
+          </p:spPr>
+          <p:style>
+            <a:lnRef idx="1">
+              <a:schemeClr val="accent1"/>
+            </a:lnRef>
+            <a:fillRef idx="0">
+              <a:schemeClr val="accent1"/>
+            </a:fillRef>
+            <a:effectRef idx="0">
+              <a:schemeClr val="accent1"/>
+            </a:effectRef>
+            <a:fontRef idx="minor">
+              <a:schemeClr val="tx1"/>
+            </a:fontRef>
+          </p:style>
+        </p:cxnSp>
+        <p:sp>
+          <p:nvSpPr>
+            <p:cNvPr id="1053" name="Rectangle: Rounded Corners 1052">
+              <a:extLst>
+                <a:ext uri="{FF2B5EF4-FFF2-40B4-BE49-F238E27FC236}">
+                  <a16:creationId xmlns:a16="http://schemas.microsoft.com/office/drawing/2014/main" id="{BB514A8F-A241-9642-A596-1D182DA8F2D2}"/>
+                </a:ext>
+              </a:extLst>
+            </p:cNvPr>
+            <p:cNvSpPr/>
+            <p:nvPr/>
+          </p:nvSpPr>
+          <p:spPr>
+            <a:xfrm>
+              <a:off x="714375" y="2906868"/>
+              <a:ext cx="3240000" cy="1080000"/>
+            </a:xfrm>
+            <a:prstGeom prst="roundRect">
+              <a:avLst/>
+            </a:prstGeom>
+            <a:noFill/>
+            <a:ln w="38100">
+              <a:solidFill>
+                <a:schemeClr val="tx1">
+                  <a:lumMod val="50000"/>
+                  <a:lumOff val="50000"/>
+                  <a:alpha val="70000"/>
+                </a:schemeClr>
+              </a:solidFill>
+            </a:ln>
+          </p:spPr>
+          <p:style>
+            <a:lnRef idx="2">
+              <a:schemeClr val="accent1">
+                <a:shade val="15000"/>
+              </a:schemeClr>
+            </a:lnRef>
+            <a:fillRef idx="1">
+              <a:schemeClr val="accent1"/>
+            </a:fillRef>
+            <a:effectRef idx="0">
+              <a:schemeClr val="accent1"/>
+            </a:effectRef>
+            <a:fontRef idx="minor">
+              <a:schemeClr val="lt1"/>
+            </a:fontRef>
+          </p:style>
+          <p:txBody>
+            <a:bodyPr rtlCol="0" anchor="ctr"/>
+            <a:lstStyle/>
+            <a:p>
+              <a:pPr algn="ctr">
+                <a:lnSpc>
+                  <a:spcPts val="1600"/>
+                </a:lnSpc>
+                <a:spcAft>
+                  <a:spcPts val="600"/>
+                </a:spcAft>
+              </a:pPr>
+              <a:r>
+                <a:rPr lang="en-US" altLang="zh-TW" b="1" dirty="0">
+                  <a:solidFill>
+                    <a:schemeClr val="tx1"/>
+                  </a:solidFill>
+                  <a:latin typeface="Liberation Mono" panose="02070409020205020404" pitchFamily="49" charset="0"/>
+                  <a:ea typeface="芫荽" pitchFamily="2" charset="-120"/>
+                  <a:cs typeface="Liberation Mono" panose="02070409020205020404" pitchFamily="49" charset="0"/>
+                </a:rPr>
+                <a:t>00_profile</a:t>
+              </a:r>
+            </a:p>
+            <a:p>
+              <a:pPr algn="ctr">
+                <a:lnSpc>
+                  <a:spcPts val="1600"/>
+                </a:lnSpc>
+                <a:spcAft>
+                  <a:spcPts val="600"/>
+                </a:spcAft>
+              </a:pPr>
+              <a:r>
+                <a:rPr lang="en-US" sz="1600" dirty="0">
+                  <a:solidFill>
+                    <a:schemeClr val="tx1"/>
+                  </a:solidFill>
+                  <a:ea typeface="芫荽" pitchFamily="2" charset="-120"/>
+                  <a:cs typeface="芫荽" pitchFamily="2" charset="-120"/>
+                </a:rPr>
+                <a:t> Your facts: CV, résumé, publication, achievements, cover letters, SOP. The team reads here.</a:t>
+              </a:r>
+            </a:p>
+          </p:txBody>
+        </p:sp>
+        <p:grpSp>
+          <p:nvGrpSpPr>
+            <p:cNvPr id="22" name="Group 21">
+              <a:extLst>
+                <a:ext uri="{FF2B5EF4-FFF2-40B4-BE49-F238E27FC236}">
+                  <a16:creationId xmlns:a16="http://schemas.microsoft.com/office/drawing/2014/main" id="{77AB2F61-498C-773D-FE52-C6D8FC522649}"/>
+                </a:ext>
+              </a:extLst>
+            </p:cNvPr>
+            <p:cNvGrpSpPr/>
+            <p:nvPr/>
+          </p:nvGrpSpPr>
+          <p:grpSpPr>
+            <a:xfrm>
+              <a:off x="180244" y="4233696"/>
+              <a:ext cx="11160000" cy="1609456"/>
+              <a:chOff x="180244" y="4152782"/>
+              <a:chExt cx="11160000" cy="1609456"/>
+            </a:xfrm>
+          </p:grpSpPr>
+          <p:grpSp>
+            <p:nvGrpSpPr>
+              <p:cNvPr id="1055" name="Group 1054">
+                <a:extLst>
+                  <a:ext uri="{FF2B5EF4-FFF2-40B4-BE49-F238E27FC236}">
+                    <a16:creationId xmlns:a16="http://schemas.microsoft.com/office/drawing/2014/main" id="{8753D1F1-0885-EBAA-1CA5-78429C7567C3}"/>
+                  </a:ext>
+                </a:extLst>
+              </p:cNvPr>
+              <p:cNvGrpSpPr/>
+              <p:nvPr/>
+            </p:nvGrpSpPr>
+            <p:grpSpPr>
+              <a:xfrm>
+                <a:off x="320713" y="4327510"/>
+                <a:ext cx="10879062" cy="1260000"/>
+                <a:chOff x="320713" y="3980985"/>
+                <a:chExt cx="10879062" cy="1260000"/>
+              </a:xfrm>
+            </p:grpSpPr>
+            <p:sp>
+              <p:nvSpPr>
+                <p:cNvPr id="1043" name="Rectangle: Rounded Corners 1042">
+                  <a:extLst>
+                    <a:ext uri="{FF2B5EF4-FFF2-40B4-BE49-F238E27FC236}">
+                      <a16:creationId xmlns:a16="http://schemas.microsoft.com/office/drawing/2014/main" id="{AF01C68C-7590-129C-58C2-5FF79C0136AB}"/>
+                    </a:ext>
+                  </a:extLst>
+                </p:cNvPr>
+                <p:cNvSpPr/>
+                <p:nvPr/>
+              </p:nvSpPr>
+              <p:spPr>
+                <a:xfrm>
+                  <a:off x="320713" y="3980985"/>
+                  <a:ext cx="2052000" cy="1260000"/>
+                </a:xfrm>
+                <a:prstGeom prst="roundRect">
+                  <a:avLst/>
+                </a:prstGeom>
+                <a:noFill/>
+                <a:ln w="50800">
+                  <a:solidFill>
+                    <a:srgbClr val="00B0F0">
+                      <a:alpha val="70000"/>
+                    </a:srgbClr>
+                  </a:solidFill>
+                </a:ln>
+              </p:spPr>
+              <p:style>
+                <a:lnRef idx="2">
+                  <a:schemeClr val="accent1">
+                    <a:shade val="15000"/>
+                  </a:schemeClr>
+                </a:lnRef>
+                <a:fillRef idx="1">
+                  <a:schemeClr val="accent1"/>
+                </a:fillRef>
+                <a:effectRef idx="0">
+                  <a:schemeClr val="accent1"/>
+                </a:effectRef>
+                <a:fontRef idx="minor">
+                  <a:schemeClr val="lt1"/>
+                </a:fontRef>
+              </p:style>
+              <p:txBody>
+                <a:bodyPr rtlCol="0" anchor="ctr"/>
+                <a:lstStyle/>
+                <a:p>
+                  <a:pPr algn="ctr">
+                    <a:lnSpc>
+                      <a:spcPts val="1600"/>
+                    </a:lnSpc>
+                    <a:spcAft>
+                      <a:spcPts val="600"/>
+                    </a:spcAft>
+                  </a:pPr>
+                  <a:r>
+                    <a:rPr lang="en-US" altLang="zh-TW" b="1" dirty="0">
+                      <a:solidFill>
+                        <a:schemeClr val="tx1"/>
+                      </a:solidFill>
+                      <a:latin typeface="Liberation Mono" panose="02070409020205020404" pitchFamily="49" charset="0"/>
+                      <a:ea typeface="芫荽" pitchFamily="2" charset="-120"/>
+                      <a:cs typeface="Liberation Mono" panose="02070409020205020404" pitchFamily="49" charset="0"/>
+                    </a:rPr>
+                    <a:t>content-strategist</a:t>
+                  </a:r>
+                </a:p>
+                <a:p>
+                  <a:pPr algn="ctr">
+                    <a:lnSpc>
+                      <a:spcPts val="1600"/>
+                    </a:lnSpc>
+                    <a:spcAft>
+                      <a:spcPts val="600"/>
+                    </a:spcAft>
+                  </a:pPr>
+                  <a:r>
+                    <a:rPr lang="en-US" sz="1600" dirty="0">
+                      <a:solidFill>
+                        <a:schemeClr val="tx1"/>
+                      </a:solidFill>
+                      <a:ea typeface="芫荽" pitchFamily="2" charset="-120"/>
+                      <a:cs typeface="芫荽" pitchFamily="2" charset="-120"/>
+                    </a:rPr>
+                    <a:t>Chief editor who routes content plan</a:t>
+                  </a:r>
+                  <a:r>
+                    <a:rPr lang="en-US" sz="1512" dirty="0">
+                      <a:solidFill>
+                        <a:schemeClr val="tx1"/>
+                      </a:solidFill>
+                      <a:ea typeface="芫荽" pitchFamily="2" charset="-120"/>
+                      <a:cs typeface="芫荽" pitchFamily="2" charset="-120"/>
+                    </a:rPr>
+                    <a:t>.</a:t>
+                  </a:r>
+                </a:p>
+              </p:txBody>
+            </p:sp>
+            <p:sp>
+              <p:nvSpPr>
+                <p:cNvPr id="1044" name="Rectangle: Rounded Corners 1043">
+                  <a:extLst>
+                    <a:ext uri="{FF2B5EF4-FFF2-40B4-BE49-F238E27FC236}">
+                      <a16:creationId xmlns:a16="http://schemas.microsoft.com/office/drawing/2014/main" id="{D88FD180-B896-1B67-FD8F-839CD25E460D}"/>
+                    </a:ext>
+                  </a:extLst>
+                </p:cNvPr>
+                <p:cNvSpPr/>
+                <p:nvPr/>
+              </p:nvSpPr>
+              <p:spPr>
+                <a:xfrm>
+                  <a:off x="2527479" y="3980985"/>
+                  <a:ext cx="2052000" cy="1260000"/>
+                </a:xfrm>
+                <a:prstGeom prst="roundRect">
+                  <a:avLst/>
+                </a:prstGeom>
+                <a:noFill/>
+                <a:ln w="50800">
+                  <a:solidFill>
+                    <a:srgbClr val="00B0F0">
+                      <a:alpha val="70000"/>
+                    </a:srgbClr>
+                  </a:solidFill>
+                </a:ln>
+              </p:spPr>
+              <p:style>
+                <a:lnRef idx="2">
+                  <a:schemeClr val="accent1">
+                    <a:shade val="15000"/>
+                  </a:schemeClr>
+                </a:lnRef>
+                <a:fillRef idx="1">
+                  <a:schemeClr val="accent1"/>
+                </a:fillRef>
+                <a:effectRef idx="0">
+                  <a:schemeClr val="accent1"/>
+                </a:effectRef>
+                <a:fontRef idx="minor">
+                  <a:schemeClr val="lt1"/>
+                </a:fontRef>
+              </p:style>
+              <p:txBody>
+                <a:bodyPr rtlCol="0" anchor="ctr"/>
+                <a:lstStyle/>
+                <a:p>
+                  <a:pPr algn="ctr">
+                    <a:lnSpc>
+                      <a:spcPts val="1600"/>
+                    </a:lnSpc>
+                    <a:spcAft>
+                      <a:spcPts val="600"/>
+                    </a:spcAft>
+                  </a:pPr>
+                  <a:r>
+                    <a:rPr lang="en-US" altLang="zh-TW" b="1" dirty="0">
+                      <a:solidFill>
+                        <a:schemeClr val="tx1"/>
+                      </a:solidFill>
+                      <a:latin typeface="Liberation Mono" panose="02070409020205020404" pitchFamily="49" charset="0"/>
+                      <a:ea typeface="芫荽" pitchFamily="2" charset="-120"/>
+                      <a:cs typeface="Liberation Mono" panose="02070409020205020404" pitchFamily="49" charset="0"/>
+                    </a:rPr>
+                    <a:t>web-designer</a:t>
+                  </a:r>
+                </a:p>
+                <a:p>
+                  <a:pPr algn="ctr">
+                    <a:lnSpc>
+                      <a:spcPts val="1600"/>
+                    </a:lnSpc>
+                    <a:spcAft>
+                      <a:spcPts val="600"/>
+                    </a:spcAft>
+                  </a:pPr>
+                  <a:r>
+                    <a:rPr lang="en-US" sz="1600" dirty="0">
+                      <a:solidFill>
+                        <a:schemeClr val="tx1"/>
+                      </a:solidFill>
+                      <a:ea typeface="芫荽" pitchFamily="2" charset="-120"/>
+                      <a:cs typeface="芫荽" pitchFamily="2" charset="-120"/>
+                    </a:rPr>
+                    <a:t>Turn vague aesthetics into CSS; dark/light.</a:t>
+                  </a:r>
+                </a:p>
+              </p:txBody>
+            </p:sp>
+            <p:sp>
+              <p:nvSpPr>
+                <p:cNvPr id="1045" name="Rectangle: Rounded Corners 1044">
+                  <a:extLst>
+                    <a:ext uri="{FF2B5EF4-FFF2-40B4-BE49-F238E27FC236}">
+                      <a16:creationId xmlns:a16="http://schemas.microsoft.com/office/drawing/2014/main" id="{88ADF975-3E97-8174-5B48-F906CF52A5FA}"/>
+                    </a:ext>
+                  </a:extLst>
+                </p:cNvPr>
+                <p:cNvSpPr/>
+                <p:nvPr/>
+              </p:nvSpPr>
+              <p:spPr>
+                <a:xfrm>
+                  <a:off x="4734245" y="3980985"/>
+                  <a:ext cx="2052000" cy="1260000"/>
+                </a:xfrm>
+                <a:prstGeom prst="roundRect">
+                  <a:avLst/>
+                </a:prstGeom>
+                <a:noFill/>
+                <a:ln w="50800">
+                  <a:solidFill>
+                    <a:srgbClr val="00B0F0">
+                      <a:alpha val="70000"/>
+                    </a:srgbClr>
+                  </a:solidFill>
+                </a:ln>
+              </p:spPr>
+              <p:style>
+                <a:lnRef idx="2">
+                  <a:schemeClr val="accent1">
+                    <a:shade val="15000"/>
+                  </a:schemeClr>
+                </a:lnRef>
+                <a:fillRef idx="1">
+                  <a:schemeClr val="accent1"/>
+                </a:fillRef>
+                <a:effectRef idx="0">
+                  <a:schemeClr val="accent1"/>
+                </a:effectRef>
+                <a:fontRef idx="minor">
+                  <a:schemeClr val="lt1"/>
+                </a:fontRef>
+              </p:style>
+              <p:txBody>
+                <a:bodyPr rtlCol="0" anchor="ctr"/>
+                <a:lstStyle/>
+                <a:p>
+                  <a:pPr algn="ctr">
+                    <a:lnSpc>
+                      <a:spcPts val="1600"/>
+                    </a:lnSpc>
+                    <a:spcAft>
+                      <a:spcPts val="600"/>
+                    </a:spcAft>
+                  </a:pPr>
+                  <a:r>
+                    <a:rPr lang="en-US" altLang="zh-TW" b="1" dirty="0">
+                      <a:solidFill>
+                        <a:schemeClr val="tx1"/>
+                      </a:solidFill>
+                      <a:latin typeface="Liberation Mono" panose="02070409020205020404" pitchFamily="49" charset="0"/>
+                      <a:ea typeface="芫荽" pitchFamily="2" charset="-120"/>
+                      <a:cs typeface="Liberation Mono" panose="02070409020205020404" pitchFamily="49" charset="0"/>
+                    </a:rPr>
+                    <a:t>growth-marketer</a:t>
+                  </a:r>
+                </a:p>
+                <a:p>
+                  <a:pPr algn="ctr">
+                    <a:lnSpc>
+                      <a:spcPts val="1600"/>
+                    </a:lnSpc>
+                    <a:spcAft>
+                      <a:spcPts val="600"/>
+                    </a:spcAft>
+                  </a:pPr>
+                  <a:r>
+                    <a:rPr lang="en-US" sz="1600" dirty="0">
+                      <a:solidFill>
+                        <a:schemeClr val="tx1"/>
+                      </a:solidFill>
+                      <a:ea typeface="芫荽" pitchFamily="2" charset="-120"/>
+                      <a:cs typeface="芫荽" pitchFamily="2" charset="-120"/>
+                    </a:rPr>
+                    <a:t>SEO, GEO, and analytics; sitemap.</a:t>
+                  </a:r>
+                </a:p>
+              </p:txBody>
+            </p:sp>
+            <p:sp>
+              <p:nvSpPr>
+                <p:cNvPr id="1046" name="Rectangle: Rounded Corners 1045">
+                  <a:extLst>
+                    <a:ext uri="{FF2B5EF4-FFF2-40B4-BE49-F238E27FC236}">
+                      <a16:creationId xmlns:a16="http://schemas.microsoft.com/office/drawing/2014/main" id="{E20DB002-E3F8-3DA1-4174-85E05E6827DD}"/>
+                    </a:ext>
+                  </a:extLst>
+                </p:cNvPr>
+                <p:cNvSpPr/>
+                <p:nvPr/>
+              </p:nvSpPr>
+              <p:spPr>
+                <a:xfrm>
+                  <a:off x="6941011" y="3980985"/>
+                  <a:ext cx="2052000" cy="1260000"/>
+                </a:xfrm>
+                <a:prstGeom prst="roundRect">
+                  <a:avLst/>
+                </a:prstGeom>
+                <a:noFill/>
+                <a:ln w="50800">
+                  <a:solidFill>
+                    <a:srgbClr val="00B0F0">
+                      <a:alpha val="70000"/>
+                    </a:srgbClr>
+                  </a:solidFill>
+                </a:ln>
+              </p:spPr>
+              <p:style>
+                <a:lnRef idx="2">
+                  <a:schemeClr val="accent1">
+                    <a:shade val="15000"/>
+                  </a:schemeClr>
+                </a:lnRef>
+                <a:fillRef idx="1">
+                  <a:schemeClr val="accent1"/>
+                </a:fillRef>
+                <a:effectRef idx="0">
+                  <a:schemeClr val="accent1"/>
+                </a:effectRef>
+                <a:fontRef idx="minor">
+                  <a:schemeClr val="lt1"/>
+                </a:fontRef>
+              </p:style>
+              <p:txBody>
+                <a:bodyPr rtlCol="0" anchor="ctr"/>
+                <a:lstStyle/>
+                <a:p>
+                  <a:pPr algn="ctr">
+                    <a:lnSpc>
+                      <a:spcPts val="1600"/>
+                    </a:lnSpc>
+                    <a:spcAft>
+                      <a:spcPts val="600"/>
+                    </a:spcAft>
+                  </a:pPr>
+                  <a:r>
+                    <a:rPr lang="en-US" altLang="zh-TW" b="1" dirty="0">
+                      <a:solidFill>
+                        <a:schemeClr val="tx1"/>
+                      </a:solidFill>
+                      <a:latin typeface="Liberation Mono" panose="02070409020205020404" pitchFamily="49" charset="0"/>
+                      <a:ea typeface="芫荽" pitchFamily="2" charset="-120"/>
+                      <a:cs typeface="Liberation Mono" panose="02070409020205020404" pitchFamily="49" charset="0"/>
+                    </a:rPr>
+                    <a:t>site-engineer</a:t>
+                  </a:r>
+                </a:p>
+                <a:p>
+                  <a:pPr algn="ctr">
+                    <a:lnSpc>
+                      <a:spcPts val="1600"/>
+                    </a:lnSpc>
+                    <a:spcAft>
+                      <a:spcPts val="600"/>
+                    </a:spcAft>
+                  </a:pPr>
+                  <a:r>
+                    <a:rPr lang="en-US" sz="1600" dirty="0">
+                      <a:solidFill>
+                        <a:schemeClr val="tx1"/>
+                      </a:solidFill>
+                      <a:ea typeface="芫荽" pitchFamily="2" charset="-120"/>
+                      <a:cs typeface="芫荽" pitchFamily="2" charset="-120"/>
+                    </a:rPr>
+                    <a:t>Build, wire JS and includes, deploy, validate.</a:t>
+                  </a:r>
+                </a:p>
+              </p:txBody>
+            </p:sp>
+            <p:sp>
+              <p:nvSpPr>
+                <p:cNvPr id="1047" name="Rectangle: Rounded Corners 1046">
+                  <a:extLst>
+                    <a:ext uri="{FF2B5EF4-FFF2-40B4-BE49-F238E27FC236}">
+                      <a16:creationId xmlns:a16="http://schemas.microsoft.com/office/drawing/2014/main" id="{525A960F-434E-BCF2-7F85-F07E43740374}"/>
+                    </a:ext>
+                  </a:extLst>
+                </p:cNvPr>
+                <p:cNvSpPr/>
+                <p:nvPr/>
+              </p:nvSpPr>
+              <p:spPr>
+                <a:xfrm>
+                  <a:off x="9147775" y="3980985"/>
+                  <a:ext cx="2052000" cy="1260000"/>
+                </a:xfrm>
+                <a:prstGeom prst="roundRect">
+                  <a:avLst/>
+                </a:prstGeom>
+                <a:noFill/>
+                <a:ln w="50800">
+                  <a:solidFill>
+                    <a:srgbClr val="002060">
+                      <a:alpha val="70000"/>
+                    </a:srgbClr>
+                  </a:solidFill>
+                </a:ln>
+              </p:spPr>
+              <p:style>
+                <a:lnRef idx="2">
+                  <a:schemeClr val="accent1">
+                    <a:shade val="15000"/>
+                  </a:schemeClr>
+                </a:lnRef>
+                <a:fillRef idx="1">
+                  <a:schemeClr val="accent1"/>
+                </a:fillRef>
+                <a:effectRef idx="0">
+                  <a:schemeClr val="accent1"/>
+                </a:effectRef>
+                <a:fontRef idx="minor">
+                  <a:schemeClr val="lt1"/>
+                </a:fontRef>
+              </p:style>
+              <p:txBody>
+                <a:bodyPr rtlCol="0" anchor="ctr"/>
+                <a:lstStyle/>
+                <a:p>
+                  <a:pPr algn="ctr">
+                    <a:lnSpc>
+                      <a:spcPts val="1600"/>
+                    </a:lnSpc>
+                    <a:spcAft>
+                      <a:spcPts val="600"/>
+                    </a:spcAft>
+                  </a:pPr>
+                  <a:r>
+                    <a:rPr lang="en-US" altLang="zh-TW" b="1" dirty="0">
+                      <a:solidFill>
+                        <a:schemeClr val="tx1"/>
+                      </a:solidFill>
+                      <a:ea typeface="芫荽" pitchFamily="2" charset="-120"/>
+                      <a:cs typeface="芫荽" pitchFamily="2" charset="-120"/>
+                    </a:rPr>
+                    <a:t>Shared skills</a:t>
+                  </a:r>
+                </a:p>
+                <a:p>
+                  <a:pPr algn="ctr">
+                    <a:lnSpc>
+                      <a:spcPts val="1600"/>
+                    </a:lnSpc>
+                    <a:spcAft>
+                      <a:spcPts val="600"/>
+                    </a:spcAft>
+                  </a:pPr>
+                  <a:r>
+                    <a:rPr lang="en-US" sz="1600" dirty="0">
+                      <a:solidFill>
+                        <a:schemeClr val="tx1"/>
+                      </a:solidFill>
+                      <a:ea typeface="芫荽" pitchFamily="2" charset="-120"/>
+                      <a:cs typeface="芫荽" pitchFamily="2" charset="-120"/>
+                    </a:rPr>
+                    <a:t>interview-user, scholar-import, SEO-audit … (reused across agents).</a:t>
+                  </a:r>
+                </a:p>
+              </p:txBody>
+            </p:sp>
+          </p:grpSp>
+          <p:sp>
+            <p:nvSpPr>
+              <p:cNvPr id="1049" name="Left Bracket 1048">
+                <a:extLst>
+                  <a:ext uri="{FF2B5EF4-FFF2-40B4-BE49-F238E27FC236}">
+                    <a16:creationId xmlns:a16="http://schemas.microsoft.com/office/drawing/2014/main" id="{11F5DFA7-8778-5BF2-E9E0-A8F7F084E756}"/>
+                  </a:ext>
+                </a:extLst>
+              </p:cNvPr>
+              <p:cNvSpPr/>
+              <p:nvPr/>
+            </p:nvSpPr>
+            <p:spPr>
+              <a:xfrm rot="5400000">
+                <a:off x="5670244" y="-1337218"/>
+                <a:ext cx="180000" cy="11160000"/>
+              </a:xfrm>
+              <a:prstGeom prst="leftBracket">
+                <a:avLst/>
+              </a:prstGeom>
+              <a:ln w="38100">
+                <a:solidFill>
+                  <a:schemeClr val="tx1">
+                    <a:lumMod val="50000"/>
+                    <a:lumOff val="50000"/>
+                  </a:schemeClr>
+                </a:solidFill>
+                <a:tailEnd type="none"/>
+              </a:ln>
+            </p:spPr>
+            <p:style>
+              <a:lnRef idx="1">
+                <a:schemeClr val="accent1"/>
+              </a:lnRef>
+              <a:fillRef idx="0">
+                <a:schemeClr val="accent1"/>
+              </a:fillRef>
+              <a:effectRef idx="0">
+                <a:schemeClr val="accent1"/>
+              </a:effectRef>
+              <a:fontRef idx="minor">
+                <a:schemeClr val="tx1"/>
+              </a:fontRef>
+            </p:style>
+            <p:txBody>
+              <a:bodyPr rtlCol="0" anchor="ctr"/>
+              <a:lstStyle/>
+              <a:p>
+                <a:pPr algn="ctr"/>
+                <a:endParaRPr lang="en-US"/>
+              </a:p>
+            </p:txBody>
+          </p:sp>
+          <p:sp>
+            <p:nvSpPr>
+              <p:cNvPr id="1054" name="Left Bracket 1053">
+                <a:extLst>
+                  <a:ext uri="{FF2B5EF4-FFF2-40B4-BE49-F238E27FC236}">
+                    <a16:creationId xmlns:a16="http://schemas.microsoft.com/office/drawing/2014/main" id="{415374AE-CAA6-83EB-10B9-C19B57452408}"/>
+                  </a:ext>
+                </a:extLst>
+              </p:cNvPr>
+              <p:cNvSpPr/>
+              <p:nvPr/>
+            </p:nvSpPr>
+            <p:spPr>
+              <a:xfrm rot="16200000" flipV="1">
+                <a:off x="5670244" y="92238"/>
+                <a:ext cx="180000" cy="11160000"/>
+              </a:xfrm>
+              <a:prstGeom prst="leftBracket">
+                <a:avLst/>
+              </a:prstGeom>
+              <a:ln w="38100">
+                <a:solidFill>
+                  <a:schemeClr val="tx1">
+                    <a:lumMod val="50000"/>
+                    <a:lumOff val="50000"/>
+                  </a:schemeClr>
+                </a:solidFill>
+                <a:tailEnd type="none"/>
+              </a:ln>
+            </p:spPr>
+            <p:style>
+              <a:lnRef idx="1">
+                <a:schemeClr val="accent1"/>
+              </a:lnRef>
+              <a:fillRef idx="0">
+                <a:schemeClr val="accent1"/>
+              </a:fillRef>
+              <a:effectRef idx="0">
+                <a:schemeClr val="accent1"/>
+              </a:effectRef>
+              <a:fontRef idx="minor">
+                <a:schemeClr val="tx1"/>
+              </a:fontRef>
+            </p:style>
+            <p:txBody>
+              <a:bodyPr rtlCol="0" anchor="ctr"/>
+              <a:lstStyle/>
+              <a:p>
+                <a:pPr algn="ctr"/>
+                <a:endParaRPr lang="en-US"/>
+              </a:p>
+            </p:txBody>
+          </p:sp>
+        </p:grpSp>
+        <p:cxnSp>
+          <p:nvCxnSpPr>
+            <p:cNvPr id="1056" name="Straight Arrow Connector 1055">
+              <a:extLst>
+                <a:ext uri="{FF2B5EF4-FFF2-40B4-BE49-F238E27FC236}">
+                  <a16:creationId xmlns:a16="http://schemas.microsoft.com/office/drawing/2014/main" id="{D5CBED7F-A613-C511-3960-063760A2ADD9}"/>
+                </a:ext>
+              </a:extLst>
+            </p:cNvPr>
+            <p:cNvCxnSpPr>
+              <a:cxnSpLocks/>
+            </p:cNvCxnSpPr>
+            <p:nvPr/>
+          </p:nvCxnSpPr>
+          <p:spPr>
+            <a:xfrm rot="5400000">
+              <a:off x="5616244" y="6073771"/>
+              <a:ext cx="288000" cy="0"/>
+            </a:xfrm>
+            <a:prstGeom prst="straightConnector1">
+              <a:avLst/>
+            </a:prstGeom>
+            <a:ln w="38100">
+              <a:solidFill>
+                <a:schemeClr val="tx1">
+                  <a:lumMod val="50000"/>
+                  <a:lumOff val="50000"/>
+                </a:schemeClr>
+              </a:solidFill>
+              <a:tailEnd type="triangle"/>
+            </a:ln>
+          </p:spPr>
+          <p:style>
+            <a:lnRef idx="1">
+              <a:schemeClr val="accent1"/>
+            </a:lnRef>
+            <a:fillRef idx="0">
+              <a:schemeClr val="accent1"/>
+            </a:fillRef>
+            <a:effectRef idx="0">
+              <a:schemeClr val="accent1"/>
+            </a:effectRef>
+            <a:fontRef idx="minor">
+              <a:schemeClr val="tx1"/>
+            </a:fontRef>
+          </p:style>
+        </p:cxnSp>
+        <p:sp>
+          <p:nvSpPr>
+            <p:cNvPr id="1057" name="Rectangle: Rounded Corners 1056">
+              <a:extLst>
+                <a:ext uri="{FF2B5EF4-FFF2-40B4-BE49-F238E27FC236}">
+                  <a16:creationId xmlns:a16="http://schemas.microsoft.com/office/drawing/2014/main" id="{A759EDA1-48DA-BCBA-D476-9FD7D7296872}"/>
+                </a:ext>
+              </a:extLst>
+            </p:cNvPr>
+            <p:cNvSpPr/>
+            <p:nvPr/>
+          </p:nvSpPr>
+          <p:spPr>
+            <a:xfrm>
+              <a:off x="4140243" y="6330564"/>
+              <a:ext cx="3240000" cy="720000"/>
+            </a:xfrm>
+            <a:prstGeom prst="roundRect">
+              <a:avLst/>
+            </a:prstGeom>
+            <a:noFill/>
+            <a:ln w="63500">
+              <a:solidFill>
+                <a:schemeClr val="accent4">
+                  <a:alpha val="70000"/>
+                </a:schemeClr>
+              </a:solidFill>
+            </a:ln>
+          </p:spPr>
+          <p:style>
+            <a:lnRef idx="2">
+              <a:schemeClr val="accent1">
+                <a:shade val="15000"/>
+              </a:schemeClr>
+            </a:lnRef>
+            <a:fillRef idx="1">
+              <a:schemeClr val="accent1"/>
+            </a:fillRef>
+            <a:effectRef idx="0">
+              <a:schemeClr val="accent1"/>
+            </a:effectRef>
+            <a:fontRef idx="minor">
+              <a:schemeClr val="lt1"/>
+            </a:fontRef>
+          </p:style>
+          <p:txBody>
+            <a:bodyPr rtlCol="0" anchor="ctr"/>
+            <a:lstStyle/>
+            <a:p>
+              <a:pPr algn="ctr">
+                <a:lnSpc>
+                  <a:spcPts val="1600"/>
+                </a:lnSpc>
+                <a:spcAft>
+                  <a:spcPts val="600"/>
+                </a:spcAft>
+              </a:pPr>
+              <a:r>
+                <a:rPr lang="en-US" altLang="zh-TW" b="1" dirty="0">
+                  <a:solidFill>
+                    <a:schemeClr val="tx1"/>
+                  </a:solidFill>
+                  <a:latin typeface="Liberation Mono" panose="02070409020205020404" pitchFamily="49" charset="0"/>
+                  <a:ea typeface="芫荽" pitchFamily="2" charset="-120"/>
+                  <a:cs typeface="Liberation Mono" panose="02070409020205020404" pitchFamily="49" charset="0"/>
+                </a:rPr>
+                <a:t>01_www</a:t>
+              </a:r>
+            </a:p>
+            <a:p>
+              <a:pPr algn="ctr">
+                <a:lnSpc>
+                  <a:spcPts val="1600"/>
+                </a:lnSpc>
+                <a:spcAft>
+                  <a:spcPts val="600"/>
+                </a:spcAft>
+              </a:pPr>
+              <a:r>
+                <a:rPr lang="en-US" sz="1600" dirty="0">
+                  <a:solidFill>
+                    <a:schemeClr val="tx1"/>
+                  </a:solidFill>
+                  <a:ea typeface="芫荽" pitchFamily="2" charset="-120"/>
+                  <a:cs typeface="芫荽" pitchFamily="2" charset="-120"/>
+                </a:rPr>
+                <a:t> Your live academic website.</a:t>
+              </a:r>
+            </a:p>
+          </p:txBody>
+        </p:sp>
+        <p:sp>
+          <p:nvSpPr>
+            <p:cNvPr id="6" name="TextBox 5">
+              <a:extLst>
+                <a:ext uri="{FF2B5EF4-FFF2-40B4-BE49-F238E27FC236}">
+                  <a16:creationId xmlns:a16="http://schemas.microsoft.com/office/drawing/2014/main" id="{0756BE1F-BDC4-0F22-CDFB-186D508064E2}"/>
+                </a:ext>
+              </a:extLst>
+            </p:cNvPr>
+            <p:cNvSpPr txBox="1"/>
+            <p:nvPr/>
+          </p:nvSpPr>
+          <p:spPr>
+            <a:xfrm>
+              <a:off x="4022857" y="5363809"/>
+              <a:ext cx="1346844" cy="369332"/>
+            </a:xfrm>
+            <a:prstGeom prst="rect">
+              <a:avLst/>
+            </a:prstGeom>
+            <a:noFill/>
+          </p:spPr>
+          <p:txBody>
+            <a:bodyPr wrap="none" rtlCol="0">
+              <a:spAutoFit/>
+            </a:bodyPr>
+            <a:lstStyle/>
+            <a:p>
+              <a:r>
+                <a:rPr lang="en-US" dirty="0">
+                  <a:solidFill>
+                    <a:schemeClr val="tx1">
+                      <a:alpha val="20000"/>
+                    </a:schemeClr>
+                  </a:solidFill>
+                </a:rPr>
+                <a:t>edchen1240</a:t>
+              </a:r>
+            </a:p>
+          </p:txBody>
+        </p:sp>
+        <p:pic>
+          <p:nvPicPr>
+            <p:cNvPr id="3" name="Picture 2">
+              <a:extLst>
+                <a:ext uri="{FF2B5EF4-FFF2-40B4-BE49-F238E27FC236}">
+                  <a16:creationId xmlns:a16="http://schemas.microsoft.com/office/drawing/2014/main" id="{05522329-97DB-989F-78E7-C5A36486F081}"/>
+                </a:ext>
+              </a:extLst>
+            </p:cNvPr>
+            <p:cNvPicPr>
+              <a:picLocks noChangeAspect="1"/>
+            </p:cNvPicPr>
+            <p:nvPr/>
+          </p:nvPicPr>
+          <p:blipFill>
+            <a:blip r:embed="rId2">
+              <a:extLst>
+                <a:ext uri="{BEBA8EAE-BF5A-486C-A8C5-ECC9F3942E4B}">
+                  <a14:imgProps xmlns:a14="http://schemas.microsoft.com/office/drawing/2010/main">
+                    <a14:imgLayer r:embed="rId3">
+                      <a14:imgEffect>
+                        <a14:brightnessContrast bright="40000"/>
+                      </a14:imgEffect>
+                    </a14:imgLayer>
+                  </a14:imgProps>
+                </a:ext>
+              </a:extLst>
+            </a:blip>
+            <a:stretch>
+              <a:fillRect/>
+            </a:stretch>
+          </p:blipFill>
+          <p:spPr>
+            <a:xfrm>
+              <a:off x="6941011" y="7485709"/>
+              <a:ext cx="4258764" cy="4645339"/>
+            </a:xfrm>
+            <a:prstGeom prst="rect">
+              <a:avLst/>
+            </a:prstGeom>
+            <a:ln>
+              <a:noFill/>
+            </a:ln>
+            <a:effectLst>
+              <a:outerShdw blurRad="292100" dist="139700" dir="2700000" algn="tl" rotWithShape="0">
+                <a:srgbClr val="333333">
+                  <a:alpha val="65000"/>
+                </a:srgbClr>
+              </a:outerShdw>
+            </a:effectLst>
+          </p:spPr>
+        </p:pic>
+        <p:sp>
+          <p:nvSpPr>
+            <p:cNvPr id="4" name="TextBox 3">
+              <a:extLst>
+                <a:ext uri="{FF2B5EF4-FFF2-40B4-BE49-F238E27FC236}">
+                  <a16:creationId xmlns:a16="http://schemas.microsoft.com/office/drawing/2014/main" id="{D2F52F15-338D-9436-5976-AF7B46510510}"/>
+                </a:ext>
+              </a:extLst>
+            </p:cNvPr>
+            <p:cNvSpPr txBox="1"/>
+            <p:nvPr/>
+          </p:nvSpPr>
+          <p:spPr>
+            <a:xfrm>
+              <a:off x="186337" y="8372382"/>
+              <a:ext cx="7059033" cy="3170099"/>
+            </a:xfrm>
+            <a:prstGeom prst="rect">
+              <a:avLst/>
+            </a:prstGeom>
+            <a:noFill/>
+          </p:spPr>
+          <p:txBody>
+            <a:bodyPr wrap="square" rtlCol="0">
+              <a:spAutoFit/>
+            </a:bodyPr>
+            <a:lstStyle/>
+            <a:p>
+              <a:r>
+                <a:rPr lang="en-US" sz="2000" dirty="0"/>
+                <a:t>📱 Responsive layout from one CSS-variable system.</a:t>
+              </a:r>
+            </a:p>
+            <a:p>
+              <a:r>
+                <a:rPr lang="en-US" sz="2000" dirty="0"/>
+                <a:t>🌗 Dark / light toggle (remembers your choice).</a:t>
+              </a:r>
+            </a:p>
+            <a:p>
+              <a:r>
+                <a:rPr lang="en-US" sz="2000" dirty="0"/>
+                <a:t>🌐 Bilingual English / </a:t>
+              </a:r>
+              <a:r>
+                <a:rPr lang="zh-TW" altLang="en-US" sz="2000" dirty="0">
+                  <a:latin typeface="芫荽" pitchFamily="2" charset="-120"/>
+                  <a:ea typeface="芫荽" pitchFamily="2" charset="-120"/>
+                  <a:cs typeface="芫荽" pitchFamily="2" charset="-120"/>
+                </a:rPr>
+                <a:t>繁體中文</a:t>
+              </a:r>
+              <a:r>
+                <a:rPr lang="zh-TW" altLang="en-US" sz="2000" dirty="0"/>
+                <a:t> </a:t>
+              </a:r>
+              <a:r>
+                <a:rPr lang="en-US" sz="2000" dirty="0"/>
+                <a:t>toggle.</a:t>
+              </a:r>
+            </a:p>
+            <a:p>
+              <a:r>
+                <a:rPr lang="en-US" sz="2000" dirty="0"/>
+                <a:t>🔎 SEO baked in — JSON-LD schema, sitemap, meta tags.</a:t>
+              </a:r>
+            </a:p>
+            <a:p>
+              <a:r>
+                <a:rPr lang="en-US" sz="2000" dirty="0"/>
+                <a:t>📈 Privacy-friendly analytics (</a:t>
+              </a:r>
+              <a:r>
+                <a:rPr lang="en-US" sz="2000" dirty="0" err="1"/>
+                <a:t>GoatCounter</a:t>
+              </a:r>
+              <a:r>
+                <a:rPr lang="en-US" sz="2000" dirty="0"/>
+                <a:t>, no cookies).</a:t>
+              </a:r>
+            </a:p>
+            <a:p>
+              <a:r>
+                <a:rPr lang="en-US" sz="2000" dirty="0"/>
+                <a:t>📝 Posts / projects / materials from simple JSON.</a:t>
+              </a:r>
+            </a:p>
+            <a:p>
+              <a:r>
+                <a:rPr lang="en-US" sz="2000" dirty="0"/>
+                <a:t>🤖 An AI agent team that customizes the whole thing for you.</a:t>
+              </a:r>
+            </a:p>
+            <a:p>
+              <a:r>
+                <a:rPr lang="en-US" sz="2000" dirty="0"/>
+                <a:t>⚙️ Vanilla HTML/CSS/JS — no build step, deploy anywhere.</a:t>
+              </a:r>
+            </a:p>
+            <a:p>
+              <a:endParaRPr lang="en-US" sz="2000" dirty="0"/>
+            </a:p>
+            <a:p>
+              <a:r>
+                <a:rPr lang="en-US" sz="2000" dirty="0"/>
+                <a:t>👉 </a:t>
+              </a:r>
+              <a:r>
+                <a:rPr lang="en-US" sz="2000" dirty="0">
+                  <a:hlinkClick r:id="rId4"/>
+                </a:rPr>
+                <a:t>https://github.com/edchen1240/agentic-academic-site</a:t>
+              </a:r>
+              <a:endParaRPr lang="en-US" sz="2000" dirty="0"/>
+            </a:p>
+          </p:txBody>
+        </p:sp>
+        <p:sp>
+          <p:nvSpPr>
+            <p:cNvPr id="5" name="TextBox 4">
+              <a:extLst>
+                <a:ext uri="{FF2B5EF4-FFF2-40B4-BE49-F238E27FC236}">
+                  <a16:creationId xmlns:a16="http://schemas.microsoft.com/office/drawing/2014/main" id="{BAA5C779-B67F-7C86-3407-3F84BA858DBA}"/>
+                </a:ext>
+              </a:extLst>
+            </p:cNvPr>
+            <p:cNvSpPr txBox="1"/>
+            <p:nvPr/>
+          </p:nvSpPr>
+          <p:spPr>
+            <a:xfrm>
+              <a:off x="186337" y="7377072"/>
+              <a:ext cx="1465658" cy="523220"/>
+            </a:xfrm>
+            <a:prstGeom prst="rect">
+              <a:avLst/>
+            </a:prstGeom>
+            <a:noFill/>
+          </p:spPr>
+          <p:txBody>
+            <a:bodyPr wrap="none" rtlCol="0">
+              <a:spAutoFit/>
+            </a:bodyPr>
+            <a:lstStyle/>
+            <a:p>
+              <a:pPr algn="ctr"/>
+              <a:r>
+                <a:rPr lang="en-US" sz="2800" b="1" dirty="0">
+                  <a:effectLst>
+                    <a:outerShdw blurRad="50800" dist="38100" dir="2700000" algn="tl" rotWithShape="0">
+                      <a:prstClr val="black">
+                        <a:alpha val="40000"/>
+                      </a:prstClr>
+                    </a:outerShdw>
+                  </a:effectLst>
+                </a:rPr>
+                <a:t>Features</a:t>
+              </a:r>
+            </a:p>
+          </p:txBody>
+        </p:sp>
+        <p:sp>
+          <p:nvSpPr>
+            <p:cNvPr id="18" name="TextBox 17">
+              <a:extLst>
+                <a:ext uri="{FF2B5EF4-FFF2-40B4-BE49-F238E27FC236}">
+                  <a16:creationId xmlns:a16="http://schemas.microsoft.com/office/drawing/2014/main" id="{6F00229E-3802-F6B2-7640-953BFC36BC68}"/>
+                </a:ext>
+              </a:extLst>
+            </p:cNvPr>
+            <p:cNvSpPr txBox="1"/>
+            <p:nvPr/>
+          </p:nvSpPr>
+          <p:spPr>
+            <a:xfrm>
+              <a:off x="5128419" y="7377072"/>
+              <a:ext cx="1657826" cy="523220"/>
+            </a:xfrm>
+            <a:prstGeom prst="rect">
+              <a:avLst/>
+            </a:prstGeom>
+            <a:noFill/>
+          </p:spPr>
+          <p:txBody>
+            <a:bodyPr wrap="none" rtlCol="0">
+              <a:spAutoFit/>
+            </a:bodyPr>
+            <a:lstStyle/>
+            <a:p>
+              <a:pPr algn="ctr"/>
+              <a:r>
+                <a:rPr lang="en-US" altLang="zh-TW" sz="2800" b="1" dirty="0">
+                  <a:effectLst>
+                    <a:outerShdw blurRad="50800" dist="38100" dir="2700000" algn="tl" rotWithShape="0">
+                      <a:prstClr val="black">
+                        <a:alpha val="40000"/>
+                      </a:prstClr>
+                    </a:outerShdw>
+                  </a:effectLst>
+                </a:rPr>
+                <a:t>Easy Start</a:t>
+              </a:r>
+              <a:endParaRPr lang="en-US" sz="2800" b="1" dirty="0">
+                <a:effectLst>
+                  <a:outerShdw blurRad="50800" dist="38100" dir="2700000" algn="tl" rotWithShape="0">
+                    <a:prstClr val="black">
+                      <a:alpha val="40000"/>
+                    </a:prstClr>
+                  </a:outerShdw>
+                </a:effectLst>
+              </a:endParaRPr>
+            </a:p>
+          </p:txBody>
+        </p:sp>
+        <p:cxnSp>
+          <p:nvCxnSpPr>
+            <p:cNvPr id="20" name="Straight Connector 19">
+              <a:extLst>
+                <a:ext uri="{FF2B5EF4-FFF2-40B4-BE49-F238E27FC236}">
+                  <a16:creationId xmlns:a16="http://schemas.microsoft.com/office/drawing/2014/main" id="{3E4AAD42-50BD-CDD5-06F0-666F8D794566}"/>
+                </a:ext>
+              </a:extLst>
+            </p:cNvPr>
+            <p:cNvCxnSpPr>
+              <a:cxnSpLocks/>
+            </p:cNvCxnSpPr>
+            <p:nvPr/>
+          </p:nvCxnSpPr>
+          <p:spPr>
+            <a:xfrm>
+              <a:off x="360244" y="7308000"/>
+              <a:ext cx="10800000" cy="0"/>
+            </a:xfrm>
+            <a:prstGeom prst="line">
+              <a:avLst/>
+            </a:prstGeom>
+            <a:ln w="12700">
+              <a:solidFill>
+                <a:schemeClr val="bg1">
+                  <a:lumMod val="75000"/>
+                </a:schemeClr>
+              </a:solidFill>
+              <a:prstDash val="lgDash"/>
+            </a:ln>
+          </p:spPr>
+          <p:style>
+            <a:lnRef idx="1">
+              <a:schemeClr val="accent1"/>
+            </a:lnRef>
+            <a:fillRef idx="0">
+              <a:schemeClr val="accent1"/>
+            </a:fillRef>
+            <a:effectRef idx="0">
+              <a:schemeClr val="accent1"/>
+            </a:effectRef>
+            <a:fontRef idx="minor">
+              <a:schemeClr val="tx1"/>
+            </a:fontRef>
+          </p:style>
+        </p:cxnSp>
+      </p:grpSp>
+    </p:spTree>
+    <p:extLst>
+      <p:ext uri="{BB962C8B-B14F-4D97-AF65-F5344CB8AC3E}">
+        <p14:creationId xmlns:p14="http://schemas.microsoft.com/office/powerpoint/2010/main" val="510813964"/>
+      </p:ext>
+    </p:extLst>
+  </p:cSld>
+  <p:clrMapOvr>
+    <a:masterClrMapping/>
+  </p:clrMapOvr>
+</p:sld>
+</file>
+
+<file path=ppt/slides/slide2.xml><?xml version="1.0" encoding="utf-8"?>
+<p:sld xmlns:a="http://schemas.openxmlformats.org/drawingml/2006/main" xmlns:r="http://schemas.openxmlformats.org/officeDocument/2006/relationships" xmlns:p="http://schemas.openxmlformats.org/presentationml/2006/main">
+  <p:cSld>
+    <p:bg>
+      <p:bgPr>
+        <a:solidFill>
+          <a:schemeClr val="accent6">
+            <a:lumMod val="20000"/>
+            <a:lumOff val="80000"/>
+          </a:schemeClr>
+        </a:solidFill>
+        <a:effectLst/>
+      </p:bgPr>
+    </p:bg>
+    <p:spTree>
+      <p:nvGrpSpPr>
+        <p:cNvPr id="1" name="">
+          <a:extLst>
+            <a:ext uri="{FF2B5EF4-FFF2-40B4-BE49-F238E27FC236}">
+              <a16:creationId xmlns:a16="http://schemas.microsoft.com/office/drawing/2014/main" id="{9866962E-85CE-1C6E-C5B6-97DF415A1D45}"/>
+            </a:ext>
+          </a:extLst>
+        </p:cNvPr>
+        <p:cNvGrpSpPr/>
+        <p:nvPr/>
+      </p:nvGrpSpPr>
+      <p:grpSpPr>
+        <a:xfrm>
+          <a:off x="0" y="0"/>
+          <a:ext cx="0" cy="0"/>
+          <a:chOff x="0" y="0"/>
+          <a:chExt cx="0" cy="0"/>
+        </a:xfrm>
+      </p:grpSpPr>
+      <p:sp>
+        <p:nvSpPr>
+          <p:cNvPr id="7" name="Date Placeholder 6">
+            <a:extLst>
+              <a:ext uri="{FF2B5EF4-FFF2-40B4-BE49-F238E27FC236}">
+                <a16:creationId xmlns:a16="http://schemas.microsoft.com/office/drawing/2014/main" id="{03266C1A-7602-D84B-3FDB-1E901D203C01}"/>
+              </a:ext>
+            </a:extLst>
+          </p:cNvPr>
+          <p:cNvSpPr>
+            <a:spLocks noGrp="1"/>
+          </p:cNvSpPr>
+          <p:nvPr>
+            <p:ph type="dt" sz="half" idx="10"/>
+          </p:nvPr>
+        </p:nvSpPr>
+        <p:spPr/>
+        <p:txBody>
+          <a:bodyPr/>
+          <a:lstStyle/>
+          <a:p>
+            <a:fld id="{BD71CCD9-8406-4FA8-9511-10DB39F06237}" type="datetime1">
+              <a:rPr lang="en-US" smtClean="0"/>
+              <a:t>2026-05-30</a:t>
+            </a:fld>
+            <a:endParaRPr lang="en-US"/>
+          </a:p>
+        </p:txBody>
+      </p:sp>
+      <p:sp>
+        <p:nvSpPr>
+          <p:cNvPr id="12" name="Footer Placeholder 11">
+            <a:extLst>
+              <a:ext uri="{FF2B5EF4-FFF2-40B4-BE49-F238E27FC236}">
+                <a16:creationId xmlns:a16="http://schemas.microsoft.com/office/drawing/2014/main" id="{AF890EF4-7AD4-5258-6BDD-8C800EADB76A}"/>
+              </a:ext>
+            </a:extLst>
+          </p:cNvPr>
+          <p:cNvSpPr>
+            <a:spLocks noGrp="1"/>
+          </p:cNvSpPr>
+          <p:nvPr>
+            <p:ph type="ftr" sz="quarter" idx="11"/>
+          </p:nvPr>
+        </p:nvSpPr>
+        <p:spPr/>
+        <p:txBody>
+          <a:bodyPr/>
+          <a:lstStyle/>
+          <a:p>
+            <a:r>
+              <a:rPr lang="en-US"/>
+              <a:t>your-name@your.institute.edu</a:t>
+            </a:r>
+          </a:p>
+        </p:txBody>
+      </p:sp>
+      <p:sp>
+        <p:nvSpPr>
+          <p:cNvPr id="13" name="Slide Number Placeholder 12">
+            <a:extLst>
+              <a:ext uri="{FF2B5EF4-FFF2-40B4-BE49-F238E27FC236}">
+                <a16:creationId xmlns:a16="http://schemas.microsoft.com/office/drawing/2014/main" id="{F7A68BCA-6F6E-EA48-8C9C-56E1ED878702}"/>
+              </a:ext>
+            </a:extLst>
+          </p:cNvPr>
+          <p:cNvSpPr>
+            <a:spLocks noGrp="1"/>
+          </p:cNvSpPr>
+          <p:nvPr>
+            <p:ph type="sldNum" sz="quarter" idx="12"/>
+          </p:nvPr>
+        </p:nvSpPr>
+        <p:spPr/>
+        <p:txBody>
+          <a:bodyPr/>
+          <a:lstStyle/>
+          <a:p>
+            <a:fld id="{BE208443-9971-4CF7-AC11-FCF956BB598F}" type="slidenum">
+              <a:rPr lang="en-US" smtClean="0"/>
+              <a:t>2</a:t>
+            </a:fld>
+            <a:endParaRPr lang="en-US"/>
+          </a:p>
+        </p:txBody>
+      </p:sp>
+      <p:grpSp>
+        <p:nvGrpSpPr>
+          <p:cNvPr id="17" name="Group 16">
+            <a:extLst>
+              <a:ext uri="{FF2B5EF4-FFF2-40B4-BE49-F238E27FC236}">
+                <a16:creationId xmlns:a16="http://schemas.microsoft.com/office/drawing/2014/main" id="{B1239EF1-C278-9929-F226-5036A51BAB81}"/>
+              </a:ext>
+            </a:extLst>
+          </p:cNvPr>
+          <p:cNvGrpSpPr/>
+          <p:nvPr/>
+        </p:nvGrpSpPr>
+        <p:grpSpPr>
+          <a:xfrm>
+            <a:off x="0" y="882322"/>
+            <a:ext cx="11520488" cy="6480000"/>
+            <a:chOff x="0" y="882322"/>
+            <a:chExt cx="11520488" cy="6480000"/>
+          </a:xfrm>
+        </p:grpSpPr>
+        <p:sp>
+          <p:nvSpPr>
+            <p:cNvPr id="1033" name="Rectangle 1032">
+              <a:extLst>
+                <a:ext uri="{FF2B5EF4-FFF2-40B4-BE49-F238E27FC236}">
+                  <a16:creationId xmlns:a16="http://schemas.microsoft.com/office/drawing/2014/main" id="{DACFD9F0-9C18-FEB3-D8A9-93292536680F}"/>
+                </a:ext>
+              </a:extLst>
+            </p:cNvPr>
+            <p:cNvSpPr/>
+            <p:nvPr/>
+          </p:nvSpPr>
+          <p:spPr>
+            <a:xfrm>
+              <a:off x="0" y="882322"/>
+              <a:ext cx="11520488" cy="6480000"/>
+            </a:xfrm>
+            <a:prstGeom prst="rect">
+              <a:avLst/>
+            </a:prstGeom>
+            <a:solidFill>
+              <a:schemeClr val="bg1"/>
+            </a:solidFill>
+            <a:ln>
+              <a:noFill/>
+            </a:ln>
+          </p:spPr>
+          <p:style>
+            <a:lnRef idx="2">
+              <a:schemeClr val="accent1">
+                <a:shade val="15000"/>
+              </a:schemeClr>
+            </a:lnRef>
+            <a:fillRef idx="1">
+              <a:schemeClr val="accent1"/>
+            </a:fillRef>
+            <a:effectRef idx="0">
+              <a:schemeClr val="accent1"/>
+            </a:effectRef>
+            <a:fontRef idx="minor">
+              <a:schemeClr val="lt1"/>
+            </a:fontRef>
+          </p:style>
+          <p:txBody>
+            <a:bodyPr rtlCol="0" anchor="ctr"/>
+            <a:lstStyle/>
+            <a:p>
+              <a:pPr algn="ctr"/>
+              <a:endParaRPr lang="en-US" sz="1701"/>
+            </a:p>
+          </p:txBody>
+        </p:sp>
+        <p:sp>
+          <p:nvSpPr>
+            <p:cNvPr id="1029" name="TextBox 1028">
+              <a:extLst>
+                <a:ext uri="{FF2B5EF4-FFF2-40B4-BE49-F238E27FC236}">
+                  <a16:creationId xmlns:a16="http://schemas.microsoft.com/office/drawing/2014/main" id="{5172E5BD-51AE-7D48-C470-256EAACAB7FC}"/>
+                </a:ext>
+              </a:extLst>
+            </p:cNvPr>
+            <p:cNvSpPr txBox="1"/>
+            <p:nvPr/>
+          </p:nvSpPr>
+          <p:spPr>
+            <a:xfrm>
+              <a:off x="5864520" y="2316222"/>
+              <a:ext cx="2765501" cy="354071"/>
+            </a:xfrm>
+            <a:prstGeom prst="rect">
+              <a:avLst/>
+            </a:prstGeom>
+            <a:noFill/>
+          </p:spPr>
+          <p:txBody>
+            <a:bodyPr wrap="none" rtlCol="0">
+              <a:spAutoFit/>
+            </a:bodyPr>
+            <a:lstStyle/>
+            <a:p>
+              <a:r>
+                <a:rPr lang="en-US" sz="1701" dirty="0"/>
+                <a:t>“Make me an academic site.”</a:t>
+              </a:r>
+            </a:p>
+          </p:txBody>
+        </p:sp>
+        <p:sp>
+          <p:nvSpPr>
+            <p:cNvPr id="1031" name="TextBox 1030">
+              <a:extLst>
+                <a:ext uri="{FF2B5EF4-FFF2-40B4-BE49-F238E27FC236}">
+                  <a16:creationId xmlns:a16="http://schemas.microsoft.com/office/drawing/2014/main" id="{2893BA3A-F959-1DEB-30CD-FA2645FB7E69}"/>
+                </a:ext>
+              </a:extLst>
+            </p:cNvPr>
+            <p:cNvSpPr txBox="1"/>
+            <p:nvPr/>
+          </p:nvSpPr>
+          <p:spPr>
+            <a:xfrm>
+              <a:off x="3172627" y="963236"/>
+              <a:ext cx="5175264" cy="523220"/>
+            </a:xfrm>
+            <a:prstGeom prst="rect">
+              <a:avLst/>
+            </a:prstGeom>
+            <a:noFill/>
+          </p:spPr>
+          <p:txBody>
+            <a:bodyPr wrap="none" rtlCol="0">
+              <a:spAutoFit/>
+            </a:bodyPr>
+            <a:lstStyle/>
+            <a:p>
+              <a:pPr algn="ctr"/>
+              <a:r>
+                <a:rPr lang="en-US" sz="2800" b="1" dirty="0">
+                  <a:effectLst>
+                    <a:outerShdw blurRad="50800" dist="38100" dir="2700000" algn="tl" rotWithShape="0">
+                      <a:prstClr val="black">
+                        <a:alpha val="40000"/>
+                      </a:prstClr>
+                    </a:outerShdw>
+                  </a:effectLst>
+                </a:rPr>
+                <a:t>Agentic Academic Site - Overview</a:t>
+              </a:r>
+            </a:p>
+          </p:txBody>
+        </p:sp>
+        <p:sp>
+          <p:nvSpPr>
+            <p:cNvPr id="43" name="Rectangle: Rounded Corners 42">
+              <a:extLst>
+                <a:ext uri="{FF2B5EF4-FFF2-40B4-BE49-F238E27FC236}">
+                  <a16:creationId xmlns:a16="http://schemas.microsoft.com/office/drawing/2014/main" id="{A01FD7DD-A668-29D0-97F7-F2DE5F6455B2}"/>
+                </a:ext>
+              </a:extLst>
+            </p:cNvPr>
+            <p:cNvSpPr/>
+            <p:nvPr/>
+          </p:nvSpPr>
+          <p:spPr>
+            <a:xfrm>
+              <a:off x="4425302" y="1616373"/>
+              <a:ext cx="2700000" cy="648000"/>
+            </a:xfrm>
+            <a:prstGeom prst="roundRect">
+              <a:avLst/>
+            </a:prstGeom>
+            <a:noFill/>
+            <a:ln w="38100">
+              <a:solidFill>
+                <a:schemeClr val="tx1">
+                  <a:lumMod val="50000"/>
+                  <a:lumOff val="50000"/>
+                  <a:alpha val="70000"/>
+                </a:schemeClr>
+              </a:solidFill>
+            </a:ln>
+          </p:spPr>
+          <p:style>
+            <a:lnRef idx="2">
+              <a:schemeClr val="accent1">
+                <a:shade val="15000"/>
+              </a:schemeClr>
+            </a:lnRef>
+            <a:fillRef idx="1">
+              <a:schemeClr val="accent1"/>
+            </a:fillRef>
+            <a:effectRef idx="0">
+              <a:schemeClr val="accent1"/>
+            </a:effectRef>
+            <a:fontRef idx="minor">
+              <a:schemeClr val="lt1"/>
+            </a:fontRef>
+          </p:style>
+          <p:txBody>
+            <a:bodyPr rtlCol="0" anchor="ctr"/>
+            <a:lstStyle/>
+            <a:p>
+              <a:pPr algn="ctr"/>
+              <a:r>
+                <a:rPr lang="en-US" altLang="zh-TW" b="1" dirty="0">
+                  <a:solidFill>
+                    <a:schemeClr val="tx1"/>
+                  </a:solidFill>
+                  <a:ea typeface="芫荽" pitchFamily="2" charset="-120"/>
+                  <a:cs typeface="芫荽" pitchFamily="2" charset="-120"/>
+                </a:rPr>
+                <a:t>Human (You + Your AI)</a:t>
+              </a:r>
+            </a:p>
+            <a:p>
+              <a:pPr algn="ctr">
+                <a:lnSpc>
+                  <a:spcPts val="1512"/>
+                </a:lnSpc>
+              </a:pPr>
+              <a:r>
+                <a:rPr lang="en-US" sz="1600" dirty="0">
+                  <a:solidFill>
+                    <a:schemeClr val="tx1"/>
+                  </a:solidFill>
+                  <a:ea typeface="芫荽" pitchFamily="2" charset="-120"/>
+                  <a:cs typeface="芫荽" pitchFamily="2" charset="-120"/>
+                </a:rPr>
+                <a:t>Input command.</a:t>
+              </a:r>
+            </a:p>
+          </p:txBody>
+        </p:sp>
+        <p:cxnSp>
+          <p:nvCxnSpPr>
+            <p:cNvPr id="1041" name="Straight Arrow Connector 1040">
+              <a:extLst>
+                <a:ext uri="{FF2B5EF4-FFF2-40B4-BE49-F238E27FC236}">
+                  <a16:creationId xmlns:a16="http://schemas.microsoft.com/office/drawing/2014/main" id="{A8532D8F-2189-8E9D-2105-74320DD3A58E}"/>
+                </a:ext>
+              </a:extLst>
+            </p:cNvPr>
+            <p:cNvCxnSpPr>
+              <a:cxnSpLocks/>
+            </p:cNvCxnSpPr>
+            <p:nvPr/>
+          </p:nvCxnSpPr>
+          <p:spPr>
+            <a:xfrm rot="5400000">
               <a:off x="5616244" y="2493257"/>
               <a:ext cx="288000" cy="0"/>
             </a:xfrm>
@@ -5156,7 +5963,7 @@
             <p:cNvPr id="1042" name="Rectangle: Rounded Corners 1041">
               <a:extLst>
                 <a:ext uri="{FF2B5EF4-FFF2-40B4-BE49-F238E27FC236}">
-                  <a16:creationId xmlns:a16="http://schemas.microsoft.com/office/drawing/2014/main" id="{61F62A4A-56F2-68A7-E68F-72A3476F30CD}"/>
+                  <a16:creationId xmlns:a16="http://schemas.microsoft.com/office/drawing/2014/main" id="{75BDA93E-4C56-3237-8EA6-79B56D161ADC}"/>
                 </a:ext>
               </a:extLst>
             </p:cNvPr>
@@ -5237,7 +6044,7 @@
             <p:cNvPr id="1055" name="Group 1054">
               <a:extLst>
                 <a:ext uri="{FF2B5EF4-FFF2-40B4-BE49-F238E27FC236}">
-                  <a16:creationId xmlns:a16="http://schemas.microsoft.com/office/drawing/2014/main" id="{8753D1F1-0885-EBAA-1CA5-78429C7567C3}"/>
+                  <a16:creationId xmlns:a16="http://schemas.microsoft.com/office/drawing/2014/main" id="{C208DFD5-DDEB-4757-A47D-B80089AC44B4}"/>
                 </a:ext>
               </a:extLst>
             </p:cNvPr>
@@ -5257,7 +6064,7 @@
               <p:cNvPr id="1043" name="Rectangle: Rounded Corners 1042">
                 <a:extLst>
                   <a:ext uri="{FF2B5EF4-FFF2-40B4-BE49-F238E27FC236}">
-                    <a16:creationId xmlns:a16="http://schemas.microsoft.com/office/drawing/2014/main" id="{AF01C68C-7590-129C-58C2-5FF79C0136AB}"/>
+                    <a16:creationId xmlns:a16="http://schemas.microsoft.com/office/drawing/2014/main" id="{C8B84A20-9C3E-3A7C-042A-C7D2E636FDFA}"/>
                   </a:ext>
                 </a:extLst>
               </p:cNvPr>
@@ -5358,7 +6165,7 @@
               <p:cNvPr id="1044" name="Rectangle: Rounded Corners 1043">
                 <a:extLst>
                   <a:ext uri="{FF2B5EF4-FFF2-40B4-BE49-F238E27FC236}">
-                    <a16:creationId xmlns:a16="http://schemas.microsoft.com/office/drawing/2014/main" id="{D88FD180-B896-1B67-FD8F-839CD25E460D}"/>
+                    <a16:creationId xmlns:a16="http://schemas.microsoft.com/office/drawing/2014/main" id="{DF031812-B188-1D0D-B336-0AAACA0D0FA0}"/>
                   </a:ext>
                 </a:extLst>
               </p:cNvPr>
@@ -5449,7 +6256,7 @@
               <p:cNvPr id="1045" name="Rectangle: Rounded Corners 1044">
                 <a:extLst>
                   <a:ext uri="{FF2B5EF4-FFF2-40B4-BE49-F238E27FC236}">
-                    <a16:creationId xmlns:a16="http://schemas.microsoft.com/office/drawing/2014/main" id="{88ADF975-3E97-8174-5B48-F906CF52A5FA}"/>
+                    <a16:creationId xmlns:a16="http://schemas.microsoft.com/office/drawing/2014/main" id="{3D5285BC-2DFE-4158-B81A-8973615EF81A}"/>
                   </a:ext>
                 </a:extLst>
               </p:cNvPr>
@@ -5540,7 +6347,7 @@
               <p:cNvPr id="1046" name="Rectangle: Rounded Corners 1045">
                 <a:extLst>
                   <a:ext uri="{FF2B5EF4-FFF2-40B4-BE49-F238E27FC236}">
-                    <a16:creationId xmlns:a16="http://schemas.microsoft.com/office/drawing/2014/main" id="{E20DB002-E3F8-3DA1-4174-85E05E6827DD}"/>
+                    <a16:creationId xmlns:a16="http://schemas.microsoft.com/office/drawing/2014/main" id="{323D078B-0C3E-C853-22AF-36FCEF41F17B}"/>
                   </a:ext>
                 </a:extLst>
               </p:cNvPr>
@@ -5631,7 +6438,7 @@
               <p:cNvPr id="1047" name="Rectangle: Rounded Corners 1046">
                 <a:extLst>
                   <a:ext uri="{FF2B5EF4-FFF2-40B4-BE49-F238E27FC236}">
-                    <a16:creationId xmlns:a16="http://schemas.microsoft.com/office/drawing/2014/main" id="{525A960F-434E-BCF2-7F85-F07E43740374}"/>
+                    <a16:creationId xmlns:a16="http://schemas.microsoft.com/office/drawing/2014/main" id="{119EB461-B2D0-ABBC-6519-E60F8892406D}"/>
                   </a:ext>
                 </a:extLst>
               </p:cNvPr>
@@ -5722,7 +6529,7 @@
             <p:cNvPr id="1049" name="Left Bracket 1048">
               <a:extLst>
                 <a:ext uri="{FF2B5EF4-FFF2-40B4-BE49-F238E27FC236}">
-                  <a16:creationId xmlns:a16="http://schemas.microsoft.com/office/drawing/2014/main" id="{11F5DFA7-8778-5BF2-E9E0-A8F7F084E756}"/>
+                  <a16:creationId xmlns:a16="http://schemas.microsoft.com/office/drawing/2014/main" id="{7D6CEB20-350D-8495-6C8D-F8F628594E32}"/>
                 </a:ext>
               </a:extLst>
             </p:cNvPr>
@@ -5775,7 +6582,7 @@
             <p:cNvPr id="1050" name="Straight Arrow Connector 1049">
               <a:extLst>
                 <a:ext uri="{FF2B5EF4-FFF2-40B4-BE49-F238E27FC236}">
-                  <a16:creationId xmlns:a16="http://schemas.microsoft.com/office/drawing/2014/main" id="{3F043A0C-0DA7-12DA-8E9F-EF8C08F8EDD8}"/>
+                  <a16:creationId xmlns:a16="http://schemas.microsoft.com/office/drawing/2014/main" id="{C166DF93-BF44-3488-FDEA-FF1D2334D10B}"/>
                 </a:ext>
               </a:extLst>
             </p:cNvPr>
@@ -5822,7 +6629,7 @@
             <p:cNvPr id="1052" name="Straight Arrow Connector 1051">
               <a:extLst>
                 <a:ext uri="{FF2B5EF4-FFF2-40B4-BE49-F238E27FC236}">
-                  <a16:creationId xmlns:a16="http://schemas.microsoft.com/office/drawing/2014/main" id="{6DE930DD-EC4E-BD41-1714-21397F257CF4}"/>
+                  <a16:creationId xmlns:a16="http://schemas.microsoft.com/office/drawing/2014/main" id="{5A4F8F4B-E07D-C31E-3984-9A310EE627A2}"/>
                 </a:ext>
               </a:extLst>
             </p:cNvPr>
@@ -5869,7 +6676,7 @@
             <p:cNvPr id="1053" name="Rectangle: Rounded Corners 1052">
               <a:extLst>
                 <a:ext uri="{FF2B5EF4-FFF2-40B4-BE49-F238E27FC236}">
-                  <a16:creationId xmlns:a16="http://schemas.microsoft.com/office/drawing/2014/main" id="{BB514A8F-A241-9642-A596-1D182DA8F2D2}"/>
+                  <a16:creationId xmlns:a16="http://schemas.microsoft.com/office/drawing/2014/main" id="{61377091-0465-9C58-CE59-4157DE93138A}"/>
                 </a:ext>
               </a:extLst>
             </p:cNvPr>
@@ -5962,7 +6769,7 @@
             <p:cNvPr id="1054" name="Left Bracket 1053">
               <a:extLst>
                 <a:ext uri="{FF2B5EF4-FFF2-40B4-BE49-F238E27FC236}">
-                  <a16:creationId xmlns:a16="http://schemas.microsoft.com/office/drawing/2014/main" id="{415374AE-CAA6-83EB-10B9-C19B57452408}"/>
+                  <a16:creationId xmlns:a16="http://schemas.microsoft.com/office/drawing/2014/main" id="{527AA6FD-5256-2F9D-D397-C0546662CCDB}"/>
                 </a:ext>
               </a:extLst>
             </p:cNvPr>
@@ -6015,7 +6822,7 @@
             <p:cNvPr id="1056" name="Straight Arrow Connector 1055">
               <a:extLst>
                 <a:ext uri="{FF2B5EF4-FFF2-40B4-BE49-F238E27FC236}">
-                  <a16:creationId xmlns:a16="http://schemas.microsoft.com/office/drawing/2014/main" id="{D5CBED7F-A613-C511-3960-063760A2ADD9}"/>
+                  <a16:creationId xmlns:a16="http://schemas.microsoft.com/office/drawing/2014/main" id="{9A8B95EA-4FAB-6433-F467-0D291D3ADE9D}"/>
                 </a:ext>
               </a:extLst>
             </p:cNvPr>
@@ -6062,7 +6869,7 @@
             <p:cNvPr id="1057" name="Rectangle: Rounded Corners 1056">
               <a:extLst>
                 <a:ext uri="{FF2B5EF4-FFF2-40B4-BE49-F238E27FC236}">
-                  <a16:creationId xmlns:a16="http://schemas.microsoft.com/office/drawing/2014/main" id="{A759EDA1-48DA-BCBA-D476-9FD7D7296872}"/>
+                  <a16:creationId xmlns:a16="http://schemas.microsoft.com/office/drawing/2014/main" id="{30917940-464A-D47D-96D4-28B3415FAAEE}"/>
                 </a:ext>
               </a:extLst>
             </p:cNvPr>
@@ -6153,7 +6960,7 @@
             <p:cNvPr id="6" name="TextBox 5">
               <a:extLst>
                 <a:ext uri="{FF2B5EF4-FFF2-40B4-BE49-F238E27FC236}">
-                  <a16:creationId xmlns:a16="http://schemas.microsoft.com/office/drawing/2014/main" id="{0756BE1F-BDC4-0F22-CDFB-186D508064E2}"/>
+                  <a16:creationId xmlns:a16="http://schemas.microsoft.com/office/drawing/2014/main" id="{9D57212B-D6CC-397B-EAFE-38C8B97183EA}"/>
                 </a:ext>
               </a:extLst>
             </p:cNvPr>
@@ -6195,7 +7002,7 @@
           <p:cNvPr id="8" name="Group 7">
             <a:extLst>
               <a:ext uri="{FF2B5EF4-FFF2-40B4-BE49-F238E27FC236}">
-                <a16:creationId xmlns:a16="http://schemas.microsoft.com/office/drawing/2014/main" id="{26F21685-7756-545B-9227-698ADB1338AC}"/>
+                <a16:creationId xmlns:a16="http://schemas.microsoft.com/office/drawing/2014/main" id="{6AF1ED77-D5BF-9149-FE87-4EE8F1903D73}"/>
               </a:ext>
             </a:extLst>
           </p:cNvPr>
@@ -6215,7 +7022,7 @@
             <p:cNvPr id="9" name="Oval 8">
               <a:extLst>
                 <a:ext uri="{FF2B5EF4-FFF2-40B4-BE49-F238E27FC236}">
-                  <a16:creationId xmlns:a16="http://schemas.microsoft.com/office/drawing/2014/main" id="{FE2E22A1-6C22-A741-86AD-2B384DBBE47D}"/>
+                  <a16:creationId xmlns:a16="http://schemas.microsoft.com/office/drawing/2014/main" id="{F35B2B99-D1ED-4279-E457-5B2CCA34E377}"/>
                 </a:ext>
               </a:extLst>
             </p:cNvPr>
@@ -6267,7 +7074,7 @@
             <p:cNvPr id="10" name="Oval 9">
               <a:extLst>
                 <a:ext uri="{FF2B5EF4-FFF2-40B4-BE49-F238E27FC236}">
-                  <a16:creationId xmlns:a16="http://schemas.microsoft.com/office/drawing/2014/main" id="{7319A108-241C-63E7-2DD1-E90E54F66275}"/>
+                  <a16:creationId xmlns:a16="http://schemas.microsoft.com/office/drawing/2014/main" id="{C4861BA9-E946-774C-237E-03BAC544BCC1}"/>
                 </a:ext>
               </a:extLst>
             </p:cNvPr>
@@ -6319,7 +7126,7 @@
             <p:cNvPr id="11" name="Oval 10">
               <a:extLst>
                 <a:ext uri="{FF2B5EF4-FFF2-40B4-BE49-F238E27FC236}">
-                  <a16:creationId xmlns:a16="http://schemas.microsoft.com/office/drawing/2014/main" id="{1E5119E2-322D-0136-E4A4-09A1D4E0ED4B}"/>
+                  <a16:creationId xmlns:a16="http://schemas.microsoft.com/office/drawing/2014/main" id="{3C27474E-C94B-49B5-5053-863198222B9D}"/>
                 </a:ext>
               </a:extLst>
             </p:cNvPr>
@@ -6371,7 +7178,7 @@
             <p:cNvPr id="14" name="Oval 13">
               <a:extLst>
                 <a:ext uri="{FF2B5EF4-FFF2-40B4-BE49-F238E27FC236}">
-                  <a16:creationId xmlns:a16="http://schemas.microsoft.com/office/drawing/2014/main" id="{901DB422-DEAE-A92D-33E2-52E5CDC712AD}"/>
+                  <a16:creationId xmlns:a16="http://schemas.microsoft.com/office/drawing/2014/main" id="{E24519BA-163C-8FD3-1206-1B2138A67270}"/>
                 </a:ext>
               </a:extLst>
             </p:cNvPr>
@@ -6423,7 +7230,7 @@
             <p:cNvPr id="15" name="Oval 14">
               <a:extLst>
                 <a:ext uri="{FF2B5EF4-FFF2-40B4-BE49-F238E27FC236}">
-                  <a16:creationId xmlns:a16="http://schemas.microsoft.com/office/drawing/2014/main" id="{A1DF03A8-F2AB-0B08-94F0-0BEE333F292D}"/>
+                  <a16:creationId xmlns:a16="http://schemas.microsoft.com/office/drawing/2014/main" id="{A42332FC-7200-9360-3196-3B347876557A}"/>
                 </a:ext>
               </a:extLst>
             </p:cNvPr>
@@ -6475,7 +7282,7 @@
             <p:cNvPr id="16" name="Oval 15">
               <a:extLst>
                 <a:ext uri="{FF2B5EF4-FFF2-40B4-BE49-F238E27FC236}">
-                  <a16:creationId xmlns:a16="http://schemas.microsoft.com/office/drawing/2014/main" id="{87B96A9F-D9E6-76FE-EDC6-ADBA65FD8C76}"/>
+                  <a16:creationId xmlns:a16="http://schemas.microsoft.com/office/drawing/2014/main" id="{1FB5A69D-D305-E64E-DF7D-ABA3312D391C}"/>
                 </a:ext>
               </a:extLst>
             </p:cNvPr>
@@ -6526,7 +7333,7 @@
     </p:spTree>
     <p:extLst>
       <p:ext uri="{BB962C8B-B14F-4D97-AF65-F5344CB8AC3E}">
-        <p14:creationId xmlns:p14="http://schemas.microsoft.com/office/powerpoint/2010/main" val="510813964"/>
+        <p14:creationId xmlns:p14="http://schemas.microsoft.com/office/powerpoint/2010/main" val="206143361"/>
       </p:ext>
     </p:extLst>
   </p:cSld>

</xml_diff>